<commit_message>
Update Tool Presentation [skip-ci]
</commit_message>
<xml_diff>
--- a/docs/documentation/iics-cli-presentation.pptx
+++ b/docs/documentation/iics-cli-presentation.pptx
@@ -5,24 +5,23 @@
     <p:sldMasterId id="2147483648" r:id="rId1"/>
   </p:sldMasterIdLst>
   <p:sldIdLst>
-    <p:sldId id="256" r:id="rId7"/>
-    <p:sldId id="257" r:id="rId8"/>
-    <p:sldId id="258" r:id="rId9"/>
-    <p:sldId id="259" r:id="rId10"/>
-    <p:sldId id="260" r:id="rId11"/>
-    <p:sldId id="261" r:id="rId12"/>
-    <p:sldId id="262" r:id="rId13"/>
-    <p:sldId id="263" r:id="rId14"/>
-    <p:sldId id="264" r:id="rId15"/>
-    <p:sldId id="265" r:id="rId16"/>
-    <p:sldId id="266" r:id="rId17"/>
-    <p:sldId id="267" r:id="rId18"/>
-    <p:sldId id="268" r:id="rId19"/>
-    <p:sldId id="269" r:id="rId20"/>
-    <p:sldId id="270" r:id="rId21"/>
-    <p:sldId id="271" r:id="rId22"/>
+    <p:sldId id="256" r:id="rId2"/>
+    <p:sldId id="257" r:id="rId3"/>
+    <p:sldId id="258" r:id="rId4"/>
+    <p:sldId id="259" r:id="rId5"/>
+    <p:sldId id="260" r:id="rId6"/>
+    <p:sldId id="261" r:id="rId7"/>
+    <p:sldId id="262" r:id="rId8"/>
+    <p:sldId id="263" r:id="rId9"/>
+    <p:sldId id="264" r:id="rId10"/>
+    <p:sldId id="265" r:id="rId11"/>
+    <p:sldId id="267" r:id="rId12"/>
+    <p:sldId id="268" r:id="rId13"/>
+    <p:sldId id="269" r:id="rId14"/>
+    <p:sldId id="270" r:id="rId15"/>
+    <p:sldId id="271" r:id="rId16"/>
   </p:sldIdLst>
-  <p:sldSz cx="12188952" cy="6858000" type="screen4x3"/>
+  <p:sldSz cx="12188825" cy="6858000"/>
   <p:notesSz cx="6858000" cy="9144000"/>
   <p:defaultTextStyle>
     <a:defPPr>
@@ -119,6 +118,22 @@
       </a:defRPr>
     </a:lvl9pPr>
   </p:defaultTextStyle>
+  <p:extLst>
+    <p:ext uri="{EFAFB233-063F-42B5-8137-9DF3F51BA10A}">
+      <p15:sldGuideLst xmlns:p15="http://schemas.microsoft.com/office/powerpoint/2012/main">
+        <p15:guide id="1" orient="horz" pos="2160">
+          <p15:clr>
+            <a:srgbClr val="A4A3A4"/>
+          </p15:clr>
+        </p15:guide>
+        <p15:guide id="2" pos="2880">
+          <p15:clr>
+            <a:srgbClr val="A4A3A4"/>
+          </p15:clr>
+        </p15:guide>
+      </p15:sldGuideLst>
+    </p:ext>
+  </p:extLst>
 </p:presentation>
 </file>
 
@@ -160,10 +175,9 @@
           <a:lstStyle/>
           <a:p>
             <a:r>
-              <a:rPr lang="en-US" smtClean="0"/>
+              <a:rPr lang="en-US"/>
               <a:t>Click to edit Master title style</a:t>
             </a:r>
-            <a:endParaRPr lang="en-US"/>
           </a:p>
         </p:txBody>
       </p:sp>
@@ -279,10 +293,9 @@
           </a:lstStyle>
           <a:p>
             <a:r>
-              <a:rPr lang="en-US" smtClean="0"/>
+              <a:rPr lang="en-US"/>
               <a:t>Click to edit Master subtitle style</a:t>
             </a:r>
-            <a:endParaRPr lang="en-US"/>
           </a:p>
         </p:txBody>
       </p:sp>
@@ -303,7 +316,7 @@
           <a:p>
             <a:fld id="{5BCAD085-E8A6-8845-BD4E-CB4CCA059FC4}" type="datetimeFigureOut">
               <a:rPr lang="en-US" smtClean="0"/>
-              <a:t>1/27/13</a:t>
+              <a:t>3/11/2026</a:t>
             </a:fld>
             <a:endParaRPr lang="en-US"/>
           </a:p>
@@ -397,10 +410,9 @@
           <a:lstStyle/>
           <a:p>
             <a:r>
-              <a:rPr lang="en-US" smtClean="0"/>
+              <a:rPr lang="en-US"/>
               <a:t>Click to edit Master title style</a:t>
             </a:r>
-            <a:endParaRPr lang="en-US"/>
           </a:p>
         </p:txBody>
       </p:sp>
@@ -421,38 +433,37 @@
           <a:p>
             <a:pPr lvl="0"/>
             <a:r>
-              <a:rPr lang="en-US" smtClean="0"/>
+              <a:rPr lang="en-US"/>
               <a:t>Click to edit Master text styles</a:t>
             </a:r>
           </a:p>
           <a:p>
             <a:pPr lvl="1"/>
             <a:r>
-              <a:rPr lang="en-US" smtClean="0"/>
+              <a:rPr lang="en-US"/>
               <a:t>Second level</a:t>
             </a:r>
           </a:p>
           <a:p>
             <a:pPr lvl="2"/>
             <a:r>
-              <a:rPr lang="en-US" smtClean="0"/>
+              <a:rPr lang="en-US"/>
               <a:t>Third level</a:t>
             </a:r>
           </a:p>
           <a:p>
             <a:pPr lvl="3"/>
             <a:r>
-              <a:rPr lang="en-US" smtClean="0"/>
+              <a:rPr lang="en-US"/>
               <a:t>Fourth level</a:t>
             </a:r>
           </a:p>
           <a:p>
             <a:pPr lvl="4"/>
             <a:r>
-              <a:rPr lang="en-US" smtClean="0"/>
+              <a:rPr lang="en-US"/>
               <a:t>Fifth level</a:t>
             </a:r>
-            <a:endParaRPr lang="en-US"/>
           </a:p>
         </p:txBody>
       </p:sp>
@@ -473,7 +484,7 @@
           <a:p>
             <a:fld id="{5BCAD085-E8A6-8845-BD4E-CB4CCA059FC4}" type="datetimeFigureOut">
               <a:rPr lang="en-US" smtClean="0"/>
-              <a:t>1/27/13</a:t>
+              <a:t>3/11/2026</a:t>
             </a:fld>
             <a:endParaRPr lang="en-US"/>
           </a:p>
@@ -572,10 +583,9 @@
           <a:lstStyle/>
           <a:p>
             <a:r>
-              <a:rPr lang="en-US" smtClean="0"/>
+              <a:rPr lang="en-US"/>
               <a:t>Click to edit Master title style</a:t>
             </a:r>
-            <a:endParaRPr lang="en-US"/>
           </a:p>
         </p:txBody>
       </p:sp>
@@ -601,38 +611,37 @@
           <a:p>
             <a:pPr lvl="0"/>
             <a:r>
-              <a:rPr lang="en-US" smtClean="0"/>
+              <a:rPr lang="en-US"/>
               <a:t>Click to edit Master text styles</a:t>
             </a:r>
           </a:p>
           <a:p>
             <a:pPr lvl="1"/>
             <a:r>
-              <a:rPr lang="en-US" smtClean="0"/>
+              <a:rPr lang="en-US"/>
               <a:t>Second level</a:t>
             </a:r>
           </a:p>
           <a:p>
             <a:pPr lvl="2"/>
             <a:r>
-              <a:rPr lang="en-US" smtClean="0"/>
+              <a:rPr lang="en-US"/>
               <a:t>Third level</a:t>
             </a:r>
           </a:p>
           <a:p>
             <a:pPr lvl="3"/>
             <a:r>
-              <a:rPr lang="en-US" smtClean="0"/>
+              <a:rPr lang="en-US"/>
               <a:t>Fourth level</a:t>
             </a:r>
           </a:p>
           <a:p>
             <a:pPr lvl="4"/>
             <a:r>
-              <a:rPr lang="en-US" smtClean="0"/>
+              <a:rPr lang="en-US"/>
               <a:t>Fifth level</a:t>
             </a:r>
-            <a:endParaRPr lang="en-US"/>
           </a:p>
         </p:txBody>
       </p:sp>
@@ -653,7 +662,7 @@
           <a:p>
             <a:fld id="{5BCAD085-E8A6-8845-BD4E-CB4CCA059FC4}" type="datetimeFigureOut">
               <a:rPr lang="en-US" smtClean="0"/>
-              <a:t>1/27/13</a:t>
+              <a:t>3/11/2026</a:t>
             </a:fld>
             <a:endParaRPr lang="en-US"/>
           </a:p>
@@ -747,10 +756,9 @@
           <a:lstStyle/>
           <a:p>
             <a:r>
-              <a:rPr lang="en-US" smtClean="0"/>
+              <a:rPr lang="en-US"/>
               <a:t>Click to edit Master title style</a:t>
             </a:r>
-            <a:endParaRPr lang="en-US"/>
           </a:p>
         </p:txBody>
       </p:sp>
@@ -771,38 +779,37 @@
           <a:p>
             <a:pPr lvl="0"/>
             <a:r>
-              <a:rPr lang="en-US" smtClean="0"/>
+              <a:rPr lang="en-US"/>
               <a:t>Click to edit Master text styles</a:t>
             </a:r>
           </a:p>
           <a:p>
             <a:pPr lvl="1"/>
             <a:r>
-              <a:rPr lang="en-US" smtClean="0"/>
+              <a:rPr lang="en-US"/>
               <a:t>Second level</a:t>
             </a:r>
           </a:p>
           <a:p>
             <a:pPr lvl="2"/>
             <a:r>
-              <a:rPr lang="en-US" smtClean="0"/>
+              <a:rPr lang="en-US"/>
               <a:t>Third level</a:t>
             </a:r>
           </a:p>
           <a:p>
             <a:pPr lvl="3"/>
             <a:r>
-              <a:rPr lang="en-US" smtClean="0"/>
+              <a:rPr lang="en-US"/>
               <a:t>Fourth level</a:t>
             </a:r>
           </a:p>
           <a:p>
             <a:pPr lvl="4"/>
             <a:r>
-              <a:rPr lang="en-US" smtClean="0"/>
+              <a:rPr lang="en-US"/>
               <a:t>Fifth level</a:t>
             </a:r>
-            <a:endParaRPr lang="en-US"/>
           </a:p>
         </p:txBody>
       </p:sp>
@@ -823,7 +830,7 @@
           <a:p>
             <a:fld id="{5BCAD085-E8A6-8845-BD4E-CB4CCA059FC4}" type="datetimeFigureOut">
               <a:rPr lang="en-US" smtClean="0"/>
-              <a:t>1/27/13</a:t>
+              <a:t>3/11/2026</a:t>
             </a:fld>
             <a:endParaRPr lang="en-US"/>
           </a:p>
@@ -926,10 +933,9 @@
           </a:lstStyle>
           <a:p>
             <a:r>
-              <a:rPr lang="en-US" smtClean="0"/>
+              <a:rPr lang="en-US"/>
               <a:t>Click to edit Master title style</a:t>
             </a:r>
-            <a:endParaRPr lang="en-US"/>
           </a:p>
         </p:txBody>
       </p:sp>
@@ -1046,7 +1052,7 @@
           <a:p>
             <a:pPr lvl="0"/>
             <a:r>
-              <a:rPr lang="en-US" smtClean="0"/>
+              <a:rPr lang="en-US"/>
               <a:t>Click to edit Master text styles</a:t>
             </a:r>
           </a:p>
@@ -1069,7 +1075,7 @@
           <a:p>
             <a:fld id="{5BCAD085-E8A6-8845-BD4E-CB4CCA059FC4}" type="datetimeFigureOut">
               <a:rPr lang="en-US" smtClean="0"/>
-              <a:t>1/27/13</a:t>
+              <a:t>3/11/2026</a:t>
             </a:fld>
             <a:endParaRPr lang="en-US"/>
           </a:p>
@@ -1163,10 +1169,9 @@
           <a:lstStyle/>
           <a:p>
             <a:r>
-              <a:rPr lang="en-US" smtClean="0"/>
+              <a:rPr lang="en-US"/>
               <a:t>Click to edit Master title style</a:t>
             </a:r>
-            <a:endParaRPr lang="en-US"/>
           </a:p>
         </p:txBody>
       </p:sp>
@@ -1220,38 +1225,37 @@
           <a:p>
             <a:pPr lvl="0"/>
             <a:r>
-              <a:rPr lang="en-US" smtClean="0"/>
+              <a:rPr lang="en-US"/>
               <a:t>Click to edit Master text styles</a:t>
             </a:r>
           </a:p>
           <a:p>
             <a:pPr lvl="1"/>
             <a:r>
-              <a:rPr lang="en-US" smtClean="0"/>
+              <a:rPr lang="en-US"/>
               <a:t>Second level</a:t>
             </a:r>
           </a:p>
           <a:p>
             <a:pPr lvl="2"/>
             <a:r>
-              <a:rPr lang="en-US" smtClean="0"/>
+              <a:rPr lang="en-US"/>
               <a:t>Third level</a:t>
             </a:r>
           </a:p>
           <a:p>
             <a:pPr lvl="3"/>
             <a:r>
-              <a:rPr lang="en-US" smtClean="0"/>
+              <a:rPr lang="en-US"/>
               <a:t>Fourth level</a:t>
             </a:r>
           </a:p>
           <a:p>
             <a:pPr lvl="4"/>
             <a:r>
-              <a:rPr lang="en-US" smtClean="0"/>
+              <a:rPr lang="en-US"/>
               <a:t>Fifth level</a:t>
             </a:r>
-            <a:endParaRPr lang="en-US"/>
           </a:p>
         </p:txBody>
       </p:sp>
@@ -1305,38 +1309,37 @@
           <a:p>
             <a:pPr lvl="0"/>
             <a:r>
-              <a:rPr lang="en-US" smtClean="0"/>
+              <a:rPr lang="en-US"/>
               <a:t>Click to edit Master text styles</a:t>
             </a:r>
           </a:p>
           <a:p>
             <a:pPr lvl="1"/>
             <a:r>
-              <a:rPr lang="en-US" smtClean="0"/>
+              <a:rPr lang="en-US"/>
               <a:t>Second level</a:t>
             </a:r>
           </a:p>
           <a:p>
             <a:pPr lvl="2"/>
             <a:r>
-              <a:rPr lang="en-US" smtClean="0"/>
+              <a:rPr lang="en-US"/>
               <a:t>Third level</a:t>
             </a:r>
           </a:p>
           <a:p>
             <a:pPr lvl="3"/>
             <a:r>
-              <a:rPr lang="en-US" smtClean="0"/>
+              <a:rPr lang="en-US"/>
               <a:t>Fourth level</a:t>
             </a:r>
           </a:p>
           <a:p>
             <a:pPr lvl="4"/>
             <a:r>
-              <a:rPr lang="en-US" smtClean="0"/>
+              <a:rPr lang="en-US"/>
               <a:t>Fifth level</a:t>
             </a:r>
-            <a:endParaRPr lang="en-US"/>
           </a:p>
         </p:txBody>
       </p:sp>
@@ -1357,7 +1360,7 @@
           <a:p>
             <a:fld id="{5BCAD085-E8A6-8845-BD4E-CB4CCA059FC4}" type="datetimeFigureOut">
               <a:rPr lang="en-US" smtClean="0"/>
-              <a:t>1/27/13</a:t>
+              <a:t>3/11/2026</a:t>
             </a:fld>
             <a:endParaRPr lang="en-US"/>
           </a:p>
@@ -1455,10 +1458,9 @@
           </a:lstStyle>
           <a:p>
             <a:r>
-              <a:rPr lang="en-US" smtClean="0"/>
+              <a:rPr lang="en-US"/>
               <a:t>Click to edit Master title style</a:t>
             </a:r>
-            <a:endParaRPr lang="en-US"/>
           </a:p>
         </p:txBody>
       </p:sp>
@@ -1521,7 +1523,7 @@
           <a:p>
             <a:pPr lvl="0"/>
             <a:r>
-              <a:rPr lang="en-US" smtClean="0"/>
+              <a:rPr lang="en-US"/>
               <a:t>Click to edit Master text styles</a:t>
             </a:r>
           </a:p>
@@ -1577,38 +1579,37 @@
           <a:p>
             <a:pPr lvl="0"/>
             <a:r>
-              <a:rPr lang="en-US" smtClean="0"/>
+              <a:rPr lang="en-US"/>
               <a:t>Click to edit Master text styles</a:t>
             </a:r>
           </a:p>
           <a:p>
             <a:pPr lvl="1"/>
             <a:r>
-              <a:rPr lang="en-US" smtClean="0"/>
+              <a:rPr lang="en-US"/>
               <a:t>Second level</a:t>
             </a:r>
           </a:p>
           <a:p>
             <a:pPr lvl="2"/>
             <a:r>
-              <a:rPr lang="en-US" smtClean="0"/>
+              <a:rPr lang="en-US"/>
               <a:t>Third level</a:t>
             </a:r>
           </a:p>
           <a:p>
             <a:pPr lvl="3"/>
             <a:r>
-              <a:rPr lang="en-US" smtClean="0"/>
+              <a:rPr lang="en-US"/>
               <a:t>Fourth level</a:t>
             </a:r>
           </a:p>
           <a:p>
             <a:pPr lvl="4"/>
             <a:r>
-              <a:rPr lang="en-US" smtClean="0"/>
+              <a:rPr lang="en-US"/>
               <a:t>Fifth level</a:t>
             </a:r>
-            <a:endParaRPr lang="en-US"/>
           </a:p>
         </p:txBody>
       </p:sp>
@@ -1671,7 +1672,7 @@
           <a:p>
             <a:pPr lvl="0"/>
             <a:r>
-              <a:rPr lang="en-US" smtClean="0"/>
+              <a:rPr lang="en-US"/>
               <a:t>Click to edit Master text styles</a:t>
             </a:r>
           </a:p>
@@ -1727,38 +1728,37 @@
           <a:p>
             <a:pPr lvl="0"/>
             <a:r>
-              <a:rPr lang="en-US" smtClean="0"/>
+              <a:rPr lang="en-US"/>
               <a:t>Click to edit Master text styles</a:t>
             </a:r>
           </a:p>
           <a:p>
             <a:pPr lvl="1"/>
             <a:r>
-              <a:rPr lang="en-US" smtClean="0"/>
+              <a:rPr lang="en-US"/>
               <a:t>Second level</a:t>
             </a:r>
           </a:p>
           <a:p>
             <a:pPr lvl="2"/>
             <a:r>
-              <a:rPr lang="en-US" smtClean="0"/>
+              <a:rPr lang="en-US"/>
               <a:t>Third level</a:t>
             </a:r>
           </a:p>
           <a:p>
             <a:pPr lvl="3"/>
             <a:r>
-              <a:rPr lang="en-US" smtClean="0"/>
+              <a:rPr lang="en-US"/>
               <a:t>Fourth level</a:t>
             </a:r>
           </a:p>
           <a:p>
             <a:pPr lvl="4"/>
             <a:r>
-              <a:rPr lang="en-US" smtClean="0"/>
+              <a:rPr lang="en-US"/>
               <a:t>Fifth level</a:t>
             </a:r>
-            <a:endParaRPr lang="en-US"/>
           </a:p>
         </p:txBody>
       </p:sp>
@@ -1779,7 +1779,7 @@
           <a:p>
             <a:fld id="{5BCAD085-E8A6-8845-BD4E-CB4CCA059FC4}" type="datetimeFigureOut">
               <a:rPr lang="en-US" smtClean="0"/>
-              <a:t>1/27/13</a:t>
+              <a:t>3/11/2026</a:t>
             </a:fld>
             <a:endParaRPr lang="en-US"/>
           </a:p>
@@ -1873,10 +1873,9 @@
           <a:lstStyle/>
           <a:p>
             <a:r>
-              <a:rPr lang="en-US" smtClean="0"/>
+              <a:rPr lang="en-US"/>
               <a:t>Click to edit Master title style</a:t>
             </a:r>
-            <a:endParaRPr lang="en-US"/>
           </a:p>
         </p:txBody>
       </p:sp>
@@ -1897,7 +1896,7 @@
           <a:p>
             <a:fld id="{5BCAD085-E8A6-8845-BD4E-CB4CCA059FC4}" type="datetimeFigureOut">
               <a:rPr lang="en-US" smtClean="0"/>
-              <a:t>1/27/13</a:t>
+              <a:t>3/11/2026</a:t>
             </a:fld>
             <a:endParaRPr lang="en-US"/>
           </a:p>
@@ -1992,7 +1991,7 @@
           <a:p>
             <a:fld id="{5BCAD085-E8A6-8845-BD4E-CB4CCA059FC4}" type="datetimeFigureOut">
               <a:rPr lang="en-US" smtClean="0"/>
-              <a:t>1/27/13</a:t>
+              <a:t>3/11/2026</a:t>
             </a:fld>
             <a:endParaRPr lang="en-US"/>
           </a:p>
@@ -2095,10 +2094,9 @@
           </a:lstStyle>
           <a:p>
             <a:r>
-              <a:rPr lang="en-US" smtClean="0"/>
+              <a:rPr lang="en-US"/>
               <a:t>Click to edit Master title style</a:t>
             </a:r>
-            <a:endParaRPr lang="en-US"/>
           </a:p>
         </p:txBody>
       </p:sp>
@@ -2152,38 +2150,37 @@
           <a:p>
             <a:pPr lvl="0"/>
             <a:r>
-              <a:rPr lang="en-US" smtClean="0"/>
+              <a:rPr lang="en-US"/>
               <a:t>Click to edit Master text styles</a:t>
             </a:r>
           </a:p>
           <a:p>
             <a:pPr lvl="1"/>
             <a:r>
-              <a:rPr lang="en-US" smtClean="0"/>
+              <a:rPr lang="en-US"/>
               <a:t>Second level</a:t>
             </a:r>
           </a:p>
           <a:p>
             <a:pPr lvl="2"/>
             <a:r>
-              <a:rPr lang="en-US" smtClean="0"/>
+              <a:rPr lang="en-US"/>
               <a:t>Third level</a:t>
             </a:r>
           </a:p>
           <a:p>
             <a:pPr lvl="3"/>
             <a:r>
-              <a:rPr lang="en-US" smtClean="0"/>
+              <a:rPr lang="en-US"/>
               <a:t>Fourth level</a:t>
             </a:r>
           </a:p>
           <a:p>
             <a:pPr lvl="4"/>
             <a:r>
-              <a:rPr lang="en-US" smtClean="0"/>
+              <a:rPr lang="en-US"/>
               <a:t>Fifth level</a:t>
             </a:r>
-            <a:endParaRPr lang="en-US"/>
           </a:p>
         </p:txBody>
       </p:sp>
@@ -2246,7 +2243,7 @@
           <a:p>
             <a:pPr lvl="0"/>
             <a:r>
-              <a:rPr lang="en-US" smtClean="0"/>
+              <a:rPr lang="en-US"/>
               <a:t>Click to edit Master text styles</a:t>
             </a:r>
           </a:p>
@@ -2269,7 +2266,7 @@
           <a:p>
             <a:fld id="{5BCAD085-E8A6-8845-BD4E-CB4CCA059FC4}" type="datetimeFigureOut">
               <a:rPr lang="en-US" smtClean="0"/>
-              <a:t>1/27/13</a:t>
+              <a:t>3/11/2026</a:t>
             </a:fld>
             <a:endParaRPr lang="en-US"/>
           </a:p>
@@ -2372,10 +2369,9 @@
           </a:lstStyle>
           <a:p>
             <a:r>
-              <a:rPr lang="en-US" smtClean="0"/>
+              <a:rPr lang="en-US"/>
               <a:t>Click to edit Master title style</a:t>
             </a:r>
-            <a:endParaRPr lang="en-US"/>
           </a:p>
         </p:txBody>
       </p:sp>
@@ -2499,7 +2495,7 @@
           <a:p>
             <a:pPr lvl="0"/>
             <a:r>
-              <a:rPr lang="en-US" smtClean="0"/>
+              <a:rPr lang="en-US"/>
               <a:t>Click to edit Master text styles</a:t>
             </a:r>
           </a:p>
@@ -2522,7 +2518,7 @@
           <a:p>
             <a:fld id="{5BCAD085-E8A6-8845-BD4E-CB4CCA059FC4}" type="datetimeFigureOut">
               <a:rPr lang="en-US" smtClean="0"/>
-              <a:t>1/27/13</a:t>
+              <a:t>3/11/2026</a:t>
             </a:fld>
             <a:endParaRPr lang="en-US"/>
           </a:p>
@@ -2631,10 +2627,9 @@
           <a:lstStyle/>
           <a:p>
             <a:r>
-              <a:rPr lang="en-US" smtClean="0"/>
+              <a:rPr lang="en-US"/>
               <a:t>Click to edit Master title style</a:t>
             </a:r>
-            <a:endParaRPr lang="en-US"/>
           </a:p>
         </p:txBody>
       </p:sp>
@@ -2665,38 +2660,37 @@
           <a:p>
             <a:pPr lvl="0"/>
             <a:r>
-              <a:rPr lang="en-US" smtClean="0"/>
+              <a:rPr lang="en-US"/>
               <a:t>Click to edit Master text styles</a:t>
             </a:r>
           </a:p>
           <a:p>
             <a:pPr lvl="1"/>
             <a:r>
-              <a:rPr lang="en-US" smtClean="0"/>
+              <a:rPr lang="en-US"/>
               <a:t>Second level</a:t>
             </a:r>
           </a:p>
           <a:p>
             <a:pPr lvl="2"/>
             <a:r>
-              <a:rPr lang="en-US" smtClean="0"/>
+              <a:rPr lang="en-US"/>
               <a:t>Third level</a:t>
             </a:r>
           </a:p>
           <a:p>
             <a:pPr lvl="3"/>
             <a:r>
-              <a:rPr lang="en-US" smtClean="0"/>
+              <a:rPr lang="en-US"/>
               <a:t>Fourth level</a:t>
             </a:r>
           </a:p>
           <a:p>
             <a:pPr lvl="4"/>
             <a:r>
-              <a:rPr lang="en-US" smtClean="0"/>
+              <a:rPr lang="en-US"/>
               <a:t>Fifth level</a:t>
             </a:r>
-            <a:endParaRPr lang="en-US"/>
           </a:p>
         </p:txBody>
       </p:sp>
@@ -2735,7 +2729,7 @@
           <a:p>
             <a:fld id="{5BCAD085-E8A6-8845-BD4E-CB4CCA059FC4}" type="datetimeFigureOut">
               <a:rPr lang="en-US" smtClean="0"/>
-              <a:t>1/27/13</a:t>
+              <a:t>3/11/2026</a:t>
             </a:fld>
             <a:endParaRPr lang="en-US"/>
           </a:p>
@@ -2816,6 +2810,54 @@
               <a:t>‹#›</a:t>
             </a:fld>
             <a:endParaRPr lang="en-US"/>
+          </a:p>
+        </p:txBody>
+      </p:sp>
+      <p:sp>
+        <p:nvSpPr>
+          <p:cNvPr id="8" name="TextBox 7">
+            <a:extLst>
+              <a:ext uri="{FF2B5EF4-FFF2-40B4-BE49-F238E27FC236}">
+                <a16:creationId xmlns:a16="http://schemas.microsoft.com/office/drawing/2014/main" id="{48AD5A96-BEE0-3EA2-A659-AC9DCB1732DD}"/>
+              </a:ext>
+            </a:extLst>
+          </p:cNvPr>
+          <p:cNvSpPr txBox="1"/>
+          <p:nvPr userDrawn="1">
+            <p:extLst>
+              <p:ext uri="{1162E1C5-73C7-4A58-AE30-91384D911F3F}">
+                <p184:classification xmlns:p184="http://schemas.microsoft.com/office/powerpoint/2018/4/main" val="ftr"/>
+              </p:ext>
+            </p:extLst>
+          </p:nvPr>
+        </p:nvSpPr>
+        <p:spPr>
+          <a:xfrm>
+            <a:off x="5556250" y="6642100"/>
+            <a:ext cx="1101725" cy="152400"/>
+          </a:xfrm>
+          <a:prstGeom prst="rect">
+            <a:avLst/>
+          </a:prstGeom>
+        </p:spPr>
+        <p:txBody>
+          <a:bodyPr horzOverflow="overflow" lIns="0" tIns="0" rIns="0" bIns="0">
+            <a:spAutoFit/>
+          </a:bodyPr>
+          <a:lstStyle/>
+          <a:p>
+            <a:pPr algn="l"/>
+            <a:r>
+              <a:rPr lang="en-US" sz="1000">
+                <a:solidFill>
+                  <a:srgbClr val="000000">
+                    <a:alpha val="50000"/>
+                  </a:srgbClr>
+                </a:solidFill>
+                <a:latin typeface="Aptos" panose="020B0004020202020204" pitchFamily="34" charset="0"/>
+              </a:rPr>
+              <a:t>Classified as Public</a:t>
+            </a:r>
           </a:p>
         </p:txBody>
       </p:sp>
@@ -3094,7 +3136,7 @@
 </file>
 
 <file path=ppt/slides/slide1.xml><?xml version="1.0" encoding="utf-8"?>
-<p:sld xmlns:a="http://schemas.openxmlformats.org/drawingml/2006/main" xmlns:p="http://schemas.openxmlformats.org/presentationml/2006/main" xmlns:r="http://schemas.openxmlformats.org/officeDocument/2006/relationships">
+<p:sld xmlns:a="http://schemas.openxmlformats.org/drawingml/2006/main" xmlns:r="http://schemas.openxmlformats.org/officeDocument/2006/relationships" xmlns:p="http://schemas.openxmlformats.org/presentationml/2006/main">
   <p:cSld>
     <p:spTree>
       <p:nvGrpSpPr>
@@ -3102,7 +3144,14 @@
         <p:cNvGrpSpPr/>
         <p:nvPr/>
       </p:nvGrpSpPr>
-      <p:grpSpPr/>
+      <p:grpSpPr>
+        <a:xfrm>
+          <a:off x="0" y="0"/>
+          <a:ext cx="0" cy="0"/>
+          <a:chOff x="0" y="0"/>
+          <a:chExt cx="0" cy="0"/>
+        </a:xfrm>
+      </p:grpSpPr>
       <p:sp>
         <p:nvSpPr>
           <p:cNvPr id="2" name="Rectangle 1"/>
@@ -3143,6 +3192,7 @@
           <a:lstStyle/>
           <a:p>
             <a:pPr algn="ctr"/>
+            <a:endParaRPr/>
           </a:p>
         </p:txBody>
       </p:sp>
@@ -3186,6 +3236,7 @@
           <a:lstStyle/>
           <a:p>
             <a:pPr algn="ctr"/>
+            <a:endParaRPr/>
           </a:p>
         </p:txBody>
       </p:sp>
@@ -3338,7 +3389,7 @@
 </file>
 
 <file path=ppt/slides/slide10.xml><?xml version="1.0" encoding="utf-8"?>
-<p:sld xmlns:a="http://schemas.openxmlformats.org/drawingml/2006/main" xmlns:p="http://schemas.openxmlformats.org/presentationml/2006/main" xmlns:r="http://schemas.openxmlformats.org/officeDocument/2006/relationships">
+<p:sld xmlns:a="http://schemas.openxmlformats.org/drawingml/2006/main" xmlns:r="http://schemas.openxmlformats.org/officeDocument/2006/relationships" xmlns:p="http://schemas.openxmlformats.org/presentationml/2006/main">
   <p:cSld>
     <p:spTree>
       <p:nvGrpSpPr>
@@ -3346,7 +3397,14 @@
         <p:cNvGrpSpPr/>
         <p:nvPr/>
       </p:nvGrpSpPr>
-      <p:grpSpPr/>
+      <p:grpSpPr>
+        <a:xfrm>
+          <a:off x="0" y="0"/>
+          <a:ext cx="0" cy="0"/>
+          <a:chOff x="0" y="0"/>
+          <a:chExt cx="0" cy="0"/>
+        </a:xfrm>
+      </p:grpSpPr>
       <p:sp>
         <p:nvSpPr>
           <p:cNvPr id="2" name="Rectangle 1"/>
@@ -3387,6 +3445,7 @@
           <a:lstStyle/>
           <a:p>
             <a:pPr algn="ctr"/>
+            <a:endParaRPr/>
           </a:p>
         </p:txBody>
       </p:sp>
@@ -3500,6 +3559,7 @@
           <a:lstStyle/>
           <a:p>
             <a:pPr algn="ctr"/>
+            <a:endParaRPr/>
           </a:p>
         </p:txBody>
       </p:sp>
@@ -3683,8 +3743,20 @@
                 <a:tableStyleId>{5C22544A-7EE6-4342-B048-85BDC9FD1C3A}</a:tableStyleId>
               </a:tblPr>
               <a:tblGrid>
-                <a:gridCol w="3566160"/>
-                <a:gridCol w="3566160"/>
+                <a:gridCol w="3566160">
+                  <a:extLst>
+                    <a:ext uri="{9D8B030D-6E8A-4147-A177-3AD203B41FA5}">
+                      <a16:colId xmlns:a16="http://schemas.microsoft.com/office/drawing/2014/main" val="20000"/>
+                    </a:ext>
+                  </a:extLst>
+                </a:gridCol>
+                <a:gridCol w="3566160">
+                  <a:extLst>
+                    <a:ext uri="{9D8B030D-6E8A-4147-A177-3AD203B41FA5}">
+                      <a16:colId xmlns:a16="http://schemas.microsoft.com/office/drawing/2014/main" val="20001"/>
+                    </a:ext>
+                  </a:extLst>
+                </a:gridCol>
               </a:tblGrid>
               <a:tr h="365760">
                 <a:tc>
@@ -3694,7 +3766,7 @@
                     <a:p>
                       <a:pPr algn="ctr"/>
                       <a:r>
-                        <a:rPr b="1" sz="1300">
+                        <a:rPr sz="1300" b="1">
                           <a:solidFill>
                             <a:srgbClr val="FFFFFF"/>
                           </a:solidFill>
@@ -3717,7 +3789,7 @@
                     <a:p>
                       <a:pPr algn="ctr"/>
                       <a:r>
-                        <a:rPr b="1" sz="1300">
+                        <a:rPr sz="1300" b="1">
                           <a:solidFill>
                             <a:srgbClr val="FFFFFF"/>
                           </a:solidFill>
@@ -3733,6 +3805,11 @@
                     </a:solidFill>
                   </a:tcPr>
                 </a:tc>
+                <a:extLst>
+                  <a:ext uri="{0D108BD9-81ED-4DB2-BD59-A6C34878D82A}">
+                    <a16:rowId xmlns:a16="http://schemas.microsoft.com/office/drawing/2014/main" val="10000"/>
+                  </a:ext>
+                </a:extLst>
               </a:tr>
               <a:tr h="365760">
                 <a:tc>
@@ -3781,6 +3858,11 @@
                     </a:solidFill>
                   </a:tcPr>
                 </a:tc>
+                <a:extLst>
+                  <a:ext uri="{0D108BD9-81ED-4DB2-BD59-A6C34878D82A}">
+                    <a16:rowId xmlns:a16="http://schemas.microsoft.com/office/drawing/2014/main" val="10001"/>
+                  </a:ext>
+                </a:extLst>
               </a:tr>
               <a:tr h="365760">
                 <a:tc>
@@ -3829,6 +3911,11 @@
                     </a:solidFill>
                   </a:tcPr>
                 </a:tc>
+                <a:extLst>
+                  <a:ext uri="{0D108BD9-81ED-4DB2-BD59-A6C34878D82A}">
+                    <a16:rowId xmlns:a16="http://schemas.microsoft.com/office/drawing/2014/main" val="10002"/>
+                  </a:ext>
+                </a:extLst>
               </a:tr>
               <a:tr h="365760">
                 <a:tc>
@@ -3877,6 +3964,11 @@
                     </a:solidFill>
                   </a:tcPr>
                 </a:tc>
+                <a:extLst>
+                  <a:ext uri="{0D108BD9-81ED-4DB2-BD59-A6C34878D82A}">
+                    <a16:rowId xmlns:a16="http://schemas.microsoft.com/office/drawing/2014/main" val="10003"/>
+                  </a:ext>
+                </a:extLst>
               </a:tr>
               <a:tr h="365760">
                 <a:tc>
@@ -3925,6 +4017,11 @@
                     </a:solidFill>
                   </a:tcPr>
                 </a:tc>
+                <a:extLst>
+                  <a:ext uri="{0D108BD9-81ED-4DB2-BD59-A6C34878D82A}">
+                    <a16:rowId xmlns:a16="http://schemas.microsoft.com/office/drawing/2014/main" val="10004"/>
+                  </a:ext>
+                </a:extLst>
               </a:tr>
               <a:tr h="365760">
                 <a:tc>
@@ -3973,6 +4070,11 @@
                     </a:solidFill>
                   </a:tcPr>
                 </a:tc>
+                <a:extLst>
+                  <a:ext uri="{0D108BD9-81ED-4DB2-BD59-A6C34878D82A}">
+                    <a16:rowId xmlns:a16="http://schemas.microsoft.com/office/drawing/2014/main" val="10005"/>
+                  </a:ext>
+                </a:extLst>
               </a:tr>
               <a:tr h="365760">
                 <a:tc>
@@ -4021,6 +4123,11 @@
                     </a:solidFill>
                   </a:tcPr>
                 </a:tc>
+                <a:extLst>
+                  <a:ext uri="{0D108BD9-81ED-4DB2-BD59-A6C34878D82A}">
+                    <a16:rowId xmlns:a16="http://schemas.microsoft.com/office/drawing/2014/main" val="10006"/>
+                  </a:ext>
+                </a:extLst>
               </a:tr>
             </a:tbl>
           </a:graphicData>
@@ -4101,6 +4208,7 @@
           <a:lstStyle/>
           <a:p>
             <a:pPr algn="ctr"/>
+            <a:endParaRPr/>
           </a:p>
         </p:txBody>
       </p:sp>
@@ -4151,7 +4259,7 @@
 </file>
 
 <file path=ppt/slides/slide11.xml><?xml version="1.0" encoding="utf-8"?>
-<p:sld xmlns:a="http://schemas.openxmlformats.org/drawingml/2006/main" xmlns:p="http://schemas.openxmlformats.org/presentationml/2006/main" xmlns:r="http://schemas.openxmlformats.org/officeDocument/2006/relationships">
+<p:sld xmlns:a="http://schemas.openxmlformats.org/drawingml/2006/main" xmlns:r="http://schemas.openxmlformats.org/officeDocument/2006/relationships" xmlns:p="http://schemas.openxmlformats.org/presentationml/2006/main">
   <p:cSld>
     <p:spTree>
       <p:nvGrpSpPr>
@@ -4159,7 +4267,14 @@
         <p:cNvGrpSpPr/>
         <p:nvPr/>
       </p:nvGrpSpPr>
-      <p:grpSpPr/>
+      <p:grpSpPr>
+        <a:xfrm>
+          <a:off x="0" y="0"/>
+          <a:ext cx="0" cy="0"/>
+          <a:chOff x="0" y="0"/>
+          <a:chExt cx="0" cy="0"/>
+        </a:xfrm>
+      </p:grpSpPr>
       <p:sp>
         <p:nvSpPr>
           <p:cNvPr id="2" name="Rectangle 1"/>
@@ -4200,6 +4315,7 @@
           <a:lstStyle/>
           <a:p>
             <a:pPr algn="ctr"/>
+            <a:endParaRPr/>
           </a:p>
         </p:txBody>
       </p:sp>
@@ -4233,7 +4349,7 @@
                 </a:solidFill>
                 <a:latin typeface="Calibri"/>
               </a:rPr>
-              <a:t>Single Binary – No JVM Required</a:t>
+              <a:t>Structured Subcommands &amp; Built-in Help</a:t>
             </a:r>
           </a:p>
         </p:txBody>
@@ -4268,7 +4384,7 @@
                 </a:solidFill>
                 <a:latin typeface="Calibri"/>
               </a:rPr>
-              <a:t>Go binary vs. Java application</a:t>
+              <a:t>kubectl / gh / aws style resource-verb hierarchy</a:t>
             </a:r>
           </a:p>
         </p:txBody>
@@ -4313,6 +4429,7 @@
           <a:lstStyle/>
           <a:p>
             <a:pPr algn="ctr"/>
+            <a:endParaRPr/>
           </a:p>
         </p:txBody>
       </p:sp>
@@ -4353,240 +4470,14 @@
       </p:sp>
       <p:sp>
         <p:nvSpPr>
-          <p:cNvPr id="7" name="TextBox 6"/>
-          <p:cNvSpPr txBox="1"/>
-          <p:nvPr/>
-        </p:nvSpPr>
-        <p:spPr>
-          <a:xfrm>
-            <a:off x="457200" y="1097280"/>
-            <a:ext cx="5303520" cy="365760"/>
-          </a:xfrm>
-          <a:prstGeom prst="rect">
-            <a:avLst/>
-          </a:prstGeom>
-          <a:noFill/>
-        </p:spPr>
-        <p:txBody>
-          <a:bodyPr wrap="square">
-            <a:spAutoFit/>
-          </a:bodyPr>
-          <a:lstStyle/>
-          <a:p>
-            <a:pPr algn="l"/>
-            <a:r>
-              <a:rPr sz="1400" b="1" i="0">
-                <a:solidFill>
-                  <a:srgbClr val="CC0000"/>
-                </a:solidFill>
-                <a:latin typeface="Calibri"/>
-              </a:rPr>
-              <a:t>Official CLI – Java application</a:t>
-            </a:r>
-          </a:p>
-        </p:txBody>
-      </p:sp>
-      <p:sp>
-        <p:nvSpPr>
-          <p:cNvPr id="8" name="TextBox 7"/>
-          <p:cNvSpPr txBox="1"/>
-          <p:nvPr/>
-        </p:nvSpPr>
-        <p:spPr>
-          <a:xfrm>
-            <a:off x="457200" y="1554480"/>
-            <a:ext cx="5303520" cy="3200400"/>
-          </a:xfrm>
-          <a:prstGeom prst="rect">
-            <a:avLst/>
-          </a:prstGeom>
-          <a:noFill/>
-        </p:spPr>
-        <p:txBody>
-          <a:bodyPr wrap="square">
-            <a:spAutoFit/>
-          </a:bodyPr>
-          <a:lstStyle/>
-          <a:p>
-            <a:r>
-              <a:rPr sz="1500" b="0">
-                <a:solidFill>
-                  <a:srgbClr val="CC0000"/>
-                </a:solidFill>
-                <a:latin typeface="Calibri"/>
-              </a:rPr>
-              <a:t>•  Requires JRE installed on every machine</a:t>
-            </a:r>
-          </a:p>
-          <a:p>
-            <a:r>
-              <a:rPr sz="1500" b="0">
-                <a:solidFill>
-                  <a:srgbClr val="CC0000"/>
-                </a:solidFill>
-                <a:latin typeface="Calibri"/>
-              </a:rPr>
-              <a:t>•  JVM startup overhead on every invocation</a:t>
-            </a:r>
-          </a:p>
-          <a:p>
-            <a:r>
-              <a:rPr sz="1500" b="0">
-                <a:solidFill>
-                  <a:srgbClr val="CC0000"/>
-                </a:solidFill>
-                <a:latin typeface="Calibri"/>
-              </a:rPr>
-              <a:t>•  Larger Docker images (JRE ~200-400 MB)</a:t>
-            </a:r>
-          </a:p>
-          <a:p>
-            <a:r>
-              <a:rPr sz="1500" b="0">
-                <a:solidFill>
-                  <a:srgbClr val="CC0000"/>
-                </a:solidFill>
-                <a:latin typeface="Calibri"/>
-              </a:rPr>
-              <a:t>•  Version conflicts between projects</a:t>
-            </a:r>
-          </a:p>
-          <a:p>
-            <a:r>
-              <a:rPr sz="1500" b="0">
-                <a:solidFill>
-                  <a:srgbClr val="CC0000"/>
-                </a:solidFill>
-                <a:latin typeface="Calibri"/>
-              </a:rPr>
-              <a:t>•  Complex installation procedure</a:t>
-            </a:r>
-          </a:p>
-        </p:txBody>
-      </p:sp>
-      <p:sp>
-        <p:nvSpPr>
-          <p:cNvPr id="9" name="TextBox 8"/>
-          <p:cNvSpPr txBox="1"/>
-          <p:nvPr/>
-        </p:nvSpPr>
-        <p:spPr>
-          <a:xfrm>
-            <a:off x="6400800" y="1097280"/>
-            <a:ext cx="5303520" cy="365760"/>
-          </a:xfrm>
-          <a:prstGeom prst="rect">
-            <a:avLst/>
-          </a:prstGeom>
-          <a:noFill/>
-        </p:spPr>
-        <p:txBody>
-          <a:bodyPr wrap="square">
-            <a:spAutoFit/>
-          </a:bodyPr>
-          <a:lstStyle/>
-          <a:p>
-            <a:pPr algn="l"/>
-            <a:r>
-              <a:rPr sz="1400" b="1" i="0">
-                <a:solidFill>
-                  <a:srgbClr val="009944"/>
-                </a:solidFill>
-                <a:latin typeface="Calibri"/>
-              </a:rPr>
-              <a:t>iics-cli – compiled Go binary</a:t>
-            </a:r>
-          </a:p>
-        </p:txBody>
-      </p:sp>
-      <p:sp>
-        <p:nvSpPr>
-          <p:cNvPr id="10" name="TextBox 9"/>
-          <p:cNvSpPr txBox="1"/>
-          <p:nvPr/>
-        </p:nvSpPr>
-        <p:spPr>
-          <a:xfrm>
-            <a:off x="6400800" y="1554480"/>
-            <a:ext cx="5303520" cy="3200400"/>
-          </a:xfrm>
-          <a:prstGeom prst="rect">
-            <a:avLst/>
-          </a:prstGeom>
-          <a:noFill/>
-        </p:spPr>
-        <p:txBody>
-          <a:bodyPr wrap="square">
-            <a:spAutoFit/>
-          </a:bodyPr>
-          <a:lstStyle/>
-          <a:p>
-            <a:r>
-              <a:rPr sz="1500" b="0">
-                <a:solidFill>
-                  <a:srgbClr val="009944"/>
-                </a:solidFill>
-                <a:latin typeface="Calibri"/>
-              </a:rPr>
-              <a:t>•  Single statically compiled binary – no dependencies</a:t>
-            </a:r>
-          </a:p>
-          <a:p>
-            <a:r>
-              <a:rPr sz="1500" b="0">
-                <a:solidFill>
-                  <a:srgbClr val="009944"/>
-                </a:solidFill>
-                <a:latin typeface="Calibri"/>
-              </a:rPr>
-              <a:t>•  Linux, macOS, Windows (amd64 and arm64)</a:t>
-            </a:r>
-          </a:p>
-          <a:p>
-            <a:r>
-              <a:rPr sz="1500" b="0">
-                <a:solidFill>
-                  <a:srgbClr val="009944"/>
-                </a:solidFill>
-                <a:latin typeface="Calibri"/>
-              </a:rPr>
-              <a:t>•  Copy to PATH and run immediately</a:t>
-            </a:r>
-          </a:p>
-          <a:p>
-            <a:r>
-              <a:rPr sz="1500" b="0">
-                <a:solidFill>
-                  <a:srgbClr val="009944"/>
-                </a:solidFill>
-                <a:latin typeface="Calibri"/>
-              </a:rPr>
-              <a:t>•  ~8 MB binary – tiny Docker layer</a:t>
-            </a:r>
-          </a:p>
-          <a:p>
-            <a:r>
-              <a:rPr sz="1500" b="0">
-                <a:solidFill>
-                  <a:srgbClr val="009944"/>
-                </a:solidFill>
-                <a:latin typeface="Calibri"/>
-              </a:rPr>
-              <a:t>•  Instant startup – no JVM warmup</a:t>
-            </a:r>
-          </a:p>
-        </p:txBody>
-      </p:sp>
-      <p:sp>
-        <p:nvSpPr>
-          <p:cNvPr id="11" name="Rectangle 10"/>
+          <p:cNvPr id="7" name="Rectangle 6"/>
           <p:cNvSpPr/>
           <p:nvPr/>
         </p:nvSpPr>
         <p:spPr>
           <a:xfrm>
-            <a:off x="457200" y="4846320"/>
-            <a:ext cx="11247120" cy="1645920"/>
+            <a:off x="457200" y="1188720"/>
+            <a:ext cx="6858000" cy="5029200"/>
           </a:xfrm>
           <a:prstGeom prst="rect">
             <a:avLst/>
@@ -4617,298 +4508,7 @@
           <a:lstStyle/>
           <a:p>
             <a:pPr algn="ctr"/>
-          </a:p>
-        </p:txBody>
-      </p:sp>
-      <p:sp>
-        <p:nvSpPr>
-          <p:cNvPr id="12" name="TextBox 11"/>
-          <p:cNvSpPr txBox="1"/>
-          <p:nvPr/>
-        </p:nvSpPr>
-        <p:spPr>
-          <a:xfrm>
-            <a:off x="594360" y="4937760"/>
-            <a:ext cx="10972800" cy="1463040"/>
-          </a:xfrm>
-          <a:prstGeom prst="rect">
-            <a:avLst/>
-          </a:prstGeom>
-          <a:noFill/>
-        </p:spPr>
-        <p:txBody>
-          <a:bodyPr wrap="square">
-            <a:spAutoFit/>
-          </a:bodyPr>
-          <a:lstStyle/>
-          <a:p>
-            <a:pPr algn="l"/>
-            <a:r>
-              <a:rPr sz="1100" b="0" i="0">
-                <a:solidFill>
-                  <a:srgbClr val="A6E3A1"/>
-                </a:solidFill>
-                <a:latin typeface="Courier New"/>
-              </a:rPr>
-              <a:t># Install – one line
-curl -L https://github.com/jbrazda/iics-cli/releases/latest/download/iics_linux_amd64 \
-  -o /usr/local/bin/iics &amp;&amp; chmod +x /usr/local/bin/iics
-# Docker – minimal image
-COPY iics /usr/local/bin/iics
-# No apt-get install default-jre needed</a:t>
-            </a:r>
-          </a:p>
-        </p:txBody>
-      </p:sp>
-    </p:spTree>
-  </p:cSld>
-  <p:clrMapOvr>
-    <a:masterClrMapping/>
-  </p:clrMapOvr>
-</p:sld>
-</file>
-
-<file path=ppt/slides/slide12.xml><?xml version="1.0" encoding="utf-8"?>
-<p:sld xmlns:a="http://schemas.openxmlformats.org/drawingml/2006/main" xmlns:p="http://schemas.openxmlformats.org/presentationml/2006/main" xmlns:r="http://schemas.openxmlformats.org/officeDocument/2006/relationships">
-  <p:cSld>
-    <p:spTree>
-      <p:nvGrpSpPr>
-        <p:cNvPr id="1" name=""/>
-        <p:cNvGrpSpPr/>
-        <p:nvPr/>
-      </p:nvGrpSpPr>
-      <p:grpSpPr/>
-      <p:sp>
-        <p:nvSpPr>
-          <p:cNvPr id="2" name="Rectangle 1"/>
-          <p:cNvSpPr/>
-          <p:nvPr/>
-        </p:nvSpPr>
-        <p:spPr>
-          <a:xfrm>
-            <a:off x="0" y="0"/>
-            <a:ext cx="12188952" cy="1005840"/>
-          </a:xfrm>
-          <a:prstGeom prst="rect">
-            <a:avLst/>
-          </a:prstGeom>
-          <a:solidFill>
-            <a:srgbClr val="003366"/>
-          </a:solidFill>
-          <a:ln>
-            <a:noFill/>
-          </a:ln>
-        </p:spPr>
-        <p:style>
-          <a:lnRef idx="1">
-            <a:schemeClr val="accent1"/>
-          </a:lnRef>
-          <a:fillRef idx="3">
-            <a:schemeClr val="accent1"/>
-          </a:fillRef>
-          <a:effectRef idx="2">
-            <a:schemeClr val="accent1"/>
-          </a:effectRef>
-          <a:fontRef idx="minor">
-            <a:schemeClr val="lt1"/>
-          </a:fontRef>
-        </p:style>
-        <p:txBody>
-          <a:bodyPr rtlCol="0" anchor="ctr"/>
-          <a:lstStyle/>
-          <a:p>
-            <a:pPr algn="ctr"/>
-          </a:p>
-        </p:txBody>
-      </p:sp>
-      <p:sp>
-        <p:nvSpPr>
-          <p:cNvPr id="3" name="TextBox 2"/>
-          <p:cNvSpPr txBox="1"/>
-          <p:nvPr/>
-        </p:nvSpPr>
-        <p:spPr>
-          <a:xfrm>
-            <a:off x="274320" y="91440"/>
-            <a:ext cx="11430000" cy="640080"/>
-          </a:xfrm>
-          <a:prstGeom prst="rect">
-            <a:avLst/>
-          </a:prstGeom>
-          <a:noFill/>
-        </p:spPr>
-        <p:txBody>
-          <a:bodyPr wrap="square">
-            <a:spAutoFit/>
-          </a:bodyPr>
-          <a:lstStyle/>
-          <a:p>
-            <a:pPr algn="l"/>
-            <a:r>
-              <a:rPr sz="2800" b="1" i="0">
-                <a:solidFill>
-                  <a:srgbClr val="FFFFFF"/>
-                </a:solidFill>
-                <a:latin typeface="Calibri"/>
-              </a:rPr>
-              <a:t>Structured Subcommands &amp; Built-in Help</a:t>
-            </a:r>
-          </a:p>
-        </p:txBody>
-      </p:sp>
-      <p:sp>
-        <p:nvSpPr>
-          <p:cNvPr id="4" name="TextBox 3"/>
-          <p:cNvSpPr txBox="1"/>
-          <p:nvPr/>
-        </p:nvSpPr>
-        <p:spPr>
-          <a:xfrm>
-            <a:off x="274320" y="685800"/>
-            <a:ext cx="11430000" cy="365760"/>
-          </a:xfrm>
-          <a:prstGeom prst="rect">
-            <a:avLst/>
-          </a:prstGeom>
-          <a:noFill/>
-        </p:spPr>
-        <p:txBody>
-          <a:bodyPr wrap="square">
-            <a:spAutoFit/>
-          </a:bodyPr>
-          <a:lstStyle/>
-          <a:p>
-            <a:pPr algn="l"/>
-            <a:r>
-              <a:rPr sz="1400" b="0" i="0">
-                <a:solidFill>
-                  <a:srgbClr val="BBCCFF"/>
-                </a:solidFill>
-                <a:latin typeface="Calibri"/>
-              </a:rPr>
-              <a:t>kubectl / gh / aws style resource-verb hierarchy</a:t>
-            </a:r>
-          </a:p>
-        </p:txBody>
-      </p:sp>
-      <p:sp>
-        <p:nvSpPr>
-          <p:cNvPr id="5" name="Rectangle 4"/>
-          <p:cNvSpPr/>
-          <p:nvPr/>
-        </p:nvSpPr>
-        <p:spPr>
-          <a:xfrm>
-            <a:off x="0" y="6583680"/>
-            <a:ext cx="12188952" cy="274320"/>
-          </a:xfrm>
-          <a:prstGeom prst="rect">
-            <a:avLst/>
-          </a:prstGeom>
-          <a:solidFill>
-            <a:srgbClr val="003366"/>
-          </a:solidFill>
-          <a:ln>
-            <a:noFill/>
-          </a:ln>
-        </p:spPr>
-        <p:style>
-          <a:lnRef idx="1">
-            <a:schemeClr val="accent1"/>
-          </a:lnRef>
-          <a:fillRef idx="3">
-            <a:schemeClr val="accent1"/>
-          </a:fillRef>
-          <a:effectRef idx="2">
-            <a:schemeClr val="accent1"/>
-          </a:effectRef>
-          <a:fontRef idx="minor">
-            <a:schemeClr val="lt1"/>
-          </a:fontRef>
-        </p:style>
-        <p:txBody>
-          <a:bodyPr rtlCol="0" anchor="ctr"/>
-          <a:lstStyle/>
-          <a:p>
-            <a:pPr algn="ctr"/>
-          </a:p>
-        </p:txBody>
-      </p:sp>
-      <p:sp>
-        <p:nvSpPr>
-          <p:cNvPr id="6" name="TextBox 5"/>
-          <p:cNvSpPr txBox="1"/>
-          <p:nvPr/>
-        </p:nvSpPr>
-        <p:spPr>
-          <a:xfrm>
-            <a:off x="274320" y="6565392"/>
-            <a:ext cx="11612880" cy="274320"/>
-          </a:xfrm>
-          <a:prstGeom prst="rect">
-            <a:avLst/>
-          </a:prstGeom>
-          <a:noFill/>
-        </p:spPr>
-        <p:txBody>
-          <a:bodyPr wrap="square">
-            <a:spAutoFit/>
-          </a:bodyPr>
-          <a:lstStyle/>
-          <a:p>
-            <a:pPr algn="l"/>
-            <a:r>
-              <a:rPr sz="900" b="0" i="0">
-                <a:solidFill>
-                  <a:srgbClr val="AABBCC"/>
-                </a:solidFill>
-                <a:latin typeface="Calibri"/>
-              </a:rPr>
-              <a:t>iics-cli  |  Informatica IICS Command Line Interface</a:t>
-            </a:r>
-          </a:p>
-        </p:txBody>
-      </p:sp>
-      <p:sp>
-        <p:nvSpPr>
-          <p:cNvPr id="7" name="Rectangle 6"/>
-          <p:cNvSpPr/>
-          <p:nvPr/>
-        </p:nvSpPr>
-        <p:spPr>
-          <a:xfrm>
-            <a:off x="457200" y="1188720"/>
-            <a:ext cx="6858000" cy="5029200"/>
-          </a:xfrm>
-          <a:prstGeom prst="rect">
-            <a:avLst/>
-          </a:prstGeom>
-          <a:solidFill>
-            <a:srgbClr val="1E1E2E"/>
-          </a:solidFill>
-          <a:ln>
-            <a:noFill/>
-          </a:ln>
-        </p:spPr>
-        <p:style>
-          <a:lnRef idx="1">
-            <a:schemeClr val="accent1"/>
-          </a:lnRef>
-          <a:fillRef idx="3">
-            <a:schemeClr val="accent1"/>
-          </a:fillRef>
-          <a:effectRef idx="2">
-            <a:schemeClr val="accent1"/>
-          </a:effectRef>
-          <a:fontRef idx="minor">
-            <a:schemeClr val="lt1"/>
-          </a:fontRef>
-        </p:style>
-        <p:txBody>
-          <a:bodyPr rtlCol="0" anchor="ctr"/>
-          <a:lstStyle/>
-          <a:p>
-            <a:pPr algn="ctr"/>
+            <a:endParaRPr/>
           </a:p>
         </p:txBody>
       </p:sp>
@@ -5032,6 +4632,7 @@
           <a:lstStyle/>
           <a:p>
             <a:pPr algn="ctr"/>
+            <a:endParaRPr/>
           </a:p>
         </p:txBody>
       </p:sp>
@@ -5147,8 +4748,8 @@
 </p:sld>
 </file>
 
-<file path=ppt/slides/slide13.xml><?xml version="1.0" encoding="utf-8"?>
-<p:sld xmlns:a="http://schemas.openxmlformats.org/drawingml/2006/main" xmlns:p="http://schemas.openxmlformats.org/presentationml/2006/main" xmlns:r="http://schemas.openxmlformats.org/officeDocument/2006/relationships">
+<file path=ppt/slides/slide12.xml><?xml version="1.0" encoding="utf-8"?>
+<p:sld xmlns:a="http://schemas.openxmlformats.org/drawingml/2006/main" xmlns:r="http://schemas.openxmlformats.org/officeDocument/2006/relationships" xmlns:p="http://schemas.openxmlformats.org/presentationml/2006/main">
   <p:cSld>
     <p:spTree>
       <p:nvGrpSpPr>
@@ -5156,7 +4757,14 @@
         <p:cNvGrpSpPr/>
         <p:nvPr/>
       </p:nvGrpSpPr>
-      <p:grpSpPr/>
+      <p:grpSpPr>
+        <a:xfrm>
+          <a:off x="0" y="0"/>
+          <a:ext cx="0" cy="0"/>
+          <a:chOff x="0" y="0"/>
+          <a:chExt cx="0" cy="0"/>
+        </a:xfrm>
+      </p:grpSpPr>
       <p:sp>
         <p:nvSpPr>
           <p:cNvPr id="2" name="Rectangle 1"/>
@@ -5197,6 +4805,7 @@
           <a:lstStyle/>
           <a:p>
             <a:pPr algn="ctr"/>
+            <a:endParaRPr/>
           </a:p>
         </p:txBody>
       </p:sp>
@@ -5310,6 +4919,7 @@
           <a:lstStyle/>
           <a:p>
             <a:pPr algn="ctr"/>
+            <a:endParaRPr/>
           </a:p>
         </p:txBody>
       </p:sp>
@@ -5423,6 +5033,7 @@
           <a:lstStyle/>
           <a:p>
             <a:pPr algn="ctr"/>
+            <a:endParaRPr/>
           </a:p>
         </p:txBody>
       </p:sp>
@@ -5539,6 +5150,7 @@
           <a:lstStyle/>
           <a:p>
             <a:pPr algn="ctr"/>
+            <a:endParaRPr/>
           </a:p>
         </p:txBody>
       </p:sp>
@@ -5672,8 +5284,8 @@
 </p:sld>
 </file>
 
-<file path=ppt/slides/slide14.xml><?xml version="1.0" encoding="utf-8"?>
-<p:sld xmlns:a="http://schemas.openxmlformats.org/drawingml/2006/main" xmlns:p="http://schemas.openxmlformats.org/presentationml/2006/main" xmlns:r="http://schemas.openxmlformats.org/officeDocument/2006/relationships">
+<file path=ppt/slides/slide13.xml><?xml version="1.0" encoding="utf-8"?>
+<p:sld xmlns:a="http://schemas.openxmlformats.org/drawingml/2006/main" xmlns:r="http://schemas.openxmlformats.org/officeDocument/2006/relationships" xmlns:p="http://schemas.openxmlformats.org/presentationml/2006/main">
   <p:cSld>
     <p:spTree>
       <p:nvGrpSpPr>
@@ -5681,7 +5293,14 @@
         <p:cNvGrpSpPr/>
         <p:nvPr/>
       </p:nvGrpSpPr>
-      <p:grpSpPr/>
+      <p:grpSpPr>
+        <a:xfrm>
+          <a:off x="0" y="0"/>
+          <a:ext cx="0" cy="0"/>
+          <a:chOff x="0" y="0"/>
+          <a:chExt cx="0" cy="0"/>
+        </a:xfrm>
+      </p:grpSpPr>
       <p:sp>
         <p:nvSpPr>
           <p:cNvPr id="2" name="Rectangle 1"/>
@@ -5722,6 +5341,7 @@
           <a:lstStyle/>
           <a:p>
             <a:pPr algn="ctr"/>
+            <a:endParaRPr/>
           </a:p>
         </p:txBody>
       </p:sp>
@@ -5800,6 +5420,7 @@
           <a:lstStyle/>
           <a:p>
             <a:pPr algn="ctr"/>
+            <a:endParaRPr/>
           </a:p>
         </p:txBody>
       </p:sp>
@@ -5844,7 +5465,13 @@
           <p:cNvGraphicFramePr>
             <a:graphicFrameLocks noGrp="1"/>
           </p:cNvGraphicFramePr>
-          <p:nvPr/>
+          <p:nvPr>
+            <p:extLst>
+              <p:ext uri="{D42A27DB-BD31-4B8C-83A1-F6EECF244321}">
+                <p14:modId xmlns:p14="http://schemas.microsoft.com/office/powerpoint/2010/main" val="842640267"/>
+              </p:ext>
+            </p:extLst>
+          </p:nvPr>
         </p:nvGraphicFramePr>
         <p:xfrm>
           <a:off x="365760" y="1097280"/>
@@ -5857,9 +5484,27 @@
                 <a:tableStyleId>{5C22544A-7EE6-4342-B048-85BDC9FD1C3A}</a:tableStyleId>
               </a:tblPr>
               <a:tblGrid>
-                <a:gridCol w="3810000"/>
-                <a:gridCol w="3810000"/>
-                <a:gridCol w="3810000"/>
+                <a:gridCol w="3810000">
+                  <a:extLst>
+                    <a:ext uri="{9D8B030D-6E8A-4147-A177-3AD203B41FA5}">
+                      <a16:colId xmlns:a16="http://schemas.microsoft.com/office/drawing/2014/main" val="20000"/>
+                    </a:ext>
+                  </a:extLst>
+                </a:gridCol>
+                <a:gridCol w="3810000">
+                  <a:extLst>
+                    <a:ext uri="{9D8B030D-6E8A-4147-A177-3AD203B41FA5}">
+                      <a16:colId xmlns:a16="http://schemas.microsoft.com/office/drawing/2014/main" val="20001"/>
+                    </a:ext>
+                  </a:extLst>
+                </a:gridCol>
+                <a:gridCol w="3810000">
+                  <a:extLst>
+                    <a:ext uri="{9D8B030D-6E8A-4147-A177-3AD203B41FA5}">
+                      <a16:colId xmlns:a16="http://schemas.microsoft.com/office/drawing/2014/main" val="20002"/>
+                    </a:ext>
+                  </a:extLst>
+                </a:gridCol>
               </a:tblGrid>
               <a:tr h="340042">
                 <a:tc>
@@ -5869,7 +5514,7 @@
                     <a:p>
                       <a:pPr algn="ctr"/>
                       <a:r>
-                        <a:rPr b="1" sz="1300">
+                        <a:rPr sz="1300" b="1">
                           <a:solidFill>
                             <a:srgbClr val="FFFFFF"/>
                           </a:solidFill>
@@ -5892,7 +5537,7 @@
                     <a:p>
                       <a:pPr algn="ctr"/>
                       <a:r>
-                        <a:rPr b="1" sz="1300">
+                        <a:rPr sz="1300" b="1">
                           <a:solidFill>
                             <a:srgbClr val="FFFFFF"/>
                           </a:solidFill>
@@ -5915,7 +5560,7 @@
                     <a:p>
                       <a:pPr algn="ctr"/>
                       <a:r>
-                        <a:rPr b="1" sz="1300">
+                        <a:rPr sz="1300" b="1">
                           <a:solidFill>
                             <a:srgbClr val="FFFFFF"/>
                           </a:solidFill>
@@ -5931,6 +5576,11 @@
                     </a:solidFill>
                   </a:tcPr>
                 </a:tc>
+                <a:extLst>
+                  <a:ext uri="{0D108BD9-81ED-4DB2-BD59-A6C34878D82A}">
+                    <a16:rowId xmlns:a16="http://schemas.microsoft.com/office/drawing/2014/main" val="10000"/>
+                  </a:ext>
+                </a:extLst>
               </a:tr>
               <a:tr h="340042">
                 <a:tc>
@@ -5986,7 +5636,7 @@
                     <a:p>
                       <a:pPr algn="ctr"/>
                       <a:r>
-                        <a:rPr b="1" sz="1200">
+                        <a:rPr sz="1200" b="1">
                           <a:solidFill>
                             <a:srgbClr val="009944"/>
                           </a:solidFill>
@@ -6002,6 +5652,11 @@
                     </a:solidFill>
                   </a:tcPr>
                 </a:tc>
+                <a:extLst>
+                  <a:ext uri="{0D108BD9-81ED-4DB2-BD59-A6C34878D82A}">
+                    <a16:rowId xmlns:a16="http://schemas.microsoft.com/office/drawing/2014/main" val="10001"/>
+                  </a:ext>
+                </a:extLst>
               </a:tr>
               <a:tr h="340042">
                 <a:tc>
@@ -6057,7 +5712,7 @@
                     <a:p>
                       <a:pPr algn="ctr"/>
                       <a:r>
-                        <a:rPr b="1" sz="1200">
+                        <a:rPr sz="1200" b="1">
                           <a:solidFill>
                             <a:srgbClr val="009944"/>
                           </a:solidFill>
@@ -6073,6 +5728,11 @@
                     </a:solidFill>
                   </a:tcPr>
                 </a:tc>
+                <a:extLst>
+                  <a:ext uri="{0D108BD9-81ED-4DB2-BD59-A6C34878D82A}">
+                    <a16:rowId xmlns:a16="http://schemas.microsoft.com/office/drawing/2014/main" val="10002"/>
+                  </a:ext>
+                </a:extLst>
               </a:tr>
               <a:tr h="340042">
                 <a:tc>
@@ -6128,7 +5788,7 @@
                     <a:p>
                       <a:pPr algn="ctr"/>
                       <a:r>
-                        <a:rPr b="1" sz="1200">
+                        <a:rPr sz="1200" b="1">
                           <a:solidFill>
                             <a:srgbClr val="009944"/>
                           </a:solidFill>
@@ -6144,6 +5804,11 @@
                     </a:solidFill>
                   </a:tcPr>
                 </a:tc>
+                <a:extLst>
+                  <a:ext uri="{0D108BD9-81ED-4DB2-BD59-A6C34878D82A}">
+                    <a16:rowId xmlns:a16="http://schemas.microsoft.com/office/drawing/2014/main" val="10003"/>
+                  </a:ext>
+                </a:extLst>
               </a:tr>
               <a:tr h="340042">
                 <a:tc>
@@ -6199,7 +5864,7 @@
                     <a:p>
                       <a:pPr algn="ctr"/>
                       <a:r>
-                        <a:rPr b="1" sz="1200">
+                        <a:rPr sz="1200" b="1">
                           <a:solidFill>
                             <a:srgbClr val="009944"/>
                           </a:solidFill>
@@ -6215,6 +5880,11 @@
                     </a:solidFill>
                   </a:tcPr>
                 </a:tc>
+                <a:extLst>
+                  <a:ext uri="{0D108BD9-81ED-4DB2-BD59-A6C34878D82A}">
+                    <a16:rowId xmlns:a16="http://schemas.microsoft.com/office/drawing/2014/main" val="10004"/>
+                  </a:ext>
+                </a:extLst>
               </a:tr>
               <a:tr h="340042">
                 <a:tc>
@@ -6270,7 +5940,7 @@
                     <a:p>
                       <a:pPr algn="ctr"/>
                       <a:r>
-                        <a:rPr b="1" sz="1200">
+                        <a:rPr sz="1200" b="1">
                           <a:solidFill>
                             <a:srgbClr val="009944"/>
                           </a:solidFill>
@@ -6286,6 +5956,11 @@
                     </a:solidFill>
                   </a:tcPr>
                 </a:tc>
+                <a:extLst>
+                  <a:ext uri="{0D108BD9-81ED-4DB2-BD59-A6C34878D82A}">
+                    <a16:rowId xmlns:a16="http://schemas.microsoft.com/office/drawing/2014/main" val="10005"/>
+                  </a:ext>
+                </a:extLst>
               </a:tr>
               <a:tr h="340042">
                 <a:tc>
@@ -6341,7 +6016,7 @@
                     <a:p>
                       <a:pPr algn="ctr"/>
                       <a:r>
-                        <a:rPr b="1" sz="1200">
+                        <a:rPr sz="1200" b="1">
                           <a:solidFill>
                             <a:srgbClr val="009944"/>
                           </a:solidFill>
@@ -6357,6 +6032,11 @@
                     </a:solidFill>
                   </a:tcPr>
                 </a:tc>
+                <a:extLst>
+                  <a:ext uri="{0D108BD9-81ED-4DB2-BD59-A6C34878D82A}">
+                    <a16:rowId xmlns:a16="http://schemas.microsoft.com/office/drawing/2014/main" val="10006"/>
+                  </a:ext>
+                </a:extLst>
               </a:tr>
               <a:tr h="340042">
                 <a:tc>
@@ -6412,7 +6092,7 @@
                     <a:p>
                       <a:pPr algn="ctr"/>
                       <a:r>
-                        <a:rPr b="1" sz="1200">
+                        <a:rPr sz="1200" b="1">
                           <a:solidFill>
                             <a:srgbClr val="009944"/>
                           </a:solidFill>
@@ -6428,6 +6108,11 @@
                     </a:solidFill>
                   </a:tcPr>
                 </a:tc>
+                <a:extLst>
+                  <a:ext uri="{0D108BD9-81ED-4DB2-BD59-A6C34878D82A}">
+                    <a16:rowId xmlns:a16="http://schemas.microsoft.com/office/drawing/2014/main" val="10007"/>
+                  </a:ext>
+                </a:extLst>
               </a:tr>
               <a:tr h="340042">
                 <a:tc>
@@ -6483,7 +6168,7 @@
                     <a:p>
                       <a:pPr algn="ctr"/>
                       <a:r>
-                        <a:rPr b="1" sz="1200">
+                        <a:rPr sz="1200" b="1">
                           <a:solidFill>
                             <a:srgbClr val="009944"/>
                           </a:solidFill>
@@ -6499,6 +6184,11 @@
                     </a:solidFill>
                   </a:tcPr>
                 </a:tc>
+                <a:extLst>
+                  <a:ext uri="{0D108BD9-81ED-4DB2-BD59-A6C34878D82A}">
+                    <a16:rowId xmlns:a16="http://schemas.microsoft.com/office/drawing/2014/main" val="10008"/>
+                  </a:ext>
+                </a:extLst>
               </a:tr>
               <a:tr h="340042">
                 <a:tc>
@@ -6554,7 +6244,7 @@
                     <a:p>
                       <a:pPr algn="ctr"/>
                       <a:r>
-                        <a:rPr b="1" sz="1200">
+                        <a:rPr sz="1200" b="1">
                           <a:solidFill>
                             <a:srgbClr val="009944"/>
                           </a:solidFill>
@@ -6570,6 +6260,11 @@
                     </a:solidFill>
                   </a:tcPr>
                 </a:tc>
+                <a:extLst>
+                  <a:ext uri="{0D108BD9-81ED-4DB2-BD59-A6C34878D82A}">
+                    <a16:rowId xmlns:a16="http://schemas.microsoft.com/office/drawing/2014/main" val="10009"/>
+                  </a:ext>
+                </a:extLst>
               </a:tr>
               <a:tr h="340042">
                 <a:tc>
@@ -6625,7 +6320,7 @@
                     <a:p>
                       <a:pPr algn="ctr"/>
                       <a:r>
-                        <a:rPr b="1" sz="1200">
+                        <a:rPr sz="1200" b="1">
                           <a:solidFill>
                             <a:srgbClr val="009944"/>
                           </a:solidFill>
@@ -6641,6 +6336,11 @@
                     </a:solidFill>
                   </a:tcPr>
                 </a:tc>
+                <a:extLst>
+                  <a:ext uri="{0D108BD9-81ED-4DB2-BD59-A6C34878D82A}">
+                    <a16:rowId xmlns:a16="http://schemas.microsoft.com/office/drawing/2014/main" val="10010"/>
+                  </a:ext>
+                </a:extLst>
               </a:tr>
               <a:tr h="340042">
                 <a:tc>
@@ -6696,7 +6396,7 @@
                     <a:p>
                       <a:pPr algn="ctr"/>
                       <a:r>
-                        <a:rPr b="1" sz="1200">
+                        <a:rPr sz="1200" b="1">
                           <a:solidFill>
                             <a:srgbClr val="009944"/>
                           </a:solidFill>
@@ -6712,6 +6412,11 @@
                     </a:solidFill>
                   </a:tcPr>
                 </a:tc>
+                <a:extLst>
+                  <a:ext uri="{0D108BD9-81ED-4DB2-BD59-A6C34878D82A}">
+                    <a16:rowId xmlns:a16="http://schemas.microsoft.com/office/drawing/2014/main" val="10011"/>
+                  </a:ext>
+                </a:extLst>
               </a:tr>
               <a:tr h="340042">
                 <a:tc>
@@ -6767,7 +6472,7 @@
                     <a:p>
                       <a:pPr algn="ctr"/>
                       <a:r>
-                        <a:rPr b="1" sz="1200">
+                        <a:rPr sz="1200" b="1">
                           <a:solidFill>
                             <a:srgbClr val="009944"/>
                           </a:solidFill>
@@ -6783,6 +6488,11 @@
                     </a:solidFill>
                   </a:tcPr>
                 </a:tc>
+                <a:extLst>
+                  <a:ext uri="{0D108BD9-81ED-4DB2-BD59-A6C34878D82A}">
+                    <a16:rowId xmlns:a16="http://schemas.microsoft.com/office/drawing/2014/main" val="10012"/>
+                  </a:ext>
+                </a:extLst>
               </a:tr>
               <a:tr h="340042">
                 <a:tc>
@@ -6838,7 +6548,7 @@
                     <a:p>
                       <a:pPr algn="ctr"/>
                       <a:r>
-                        <a:rPr b="1" sz="1200">
+                        <a:rPr sz="1200" b="1">
                           <a:solidFill>
                             <a:srgbClr val="009944"/>
                           </a:solidFill>
@@ -6854,6 +6564,11 @@
                     </a:solidFill>
                   </a:tcPr>
                 </a:tc>
+                <a:extLst>
+                  <a:ext uri="{0D108BD9-81ED-4DB2-BD59-A6C34878D82A}">
+                    <a16:rowId xmlns:a16="http://schemas.microsoft.com/office/drawing/2014/main" val="10013"/>
+                  </a:ext>
+                </a:extLst>
               </a:tr>
               <a:tr h="340042">
                 <a:tc>
@@ -6863,14 +6578,29 @@
                     <a:p>
                       <a:pPr algn="l"/>
                       <a:r>
-                        <a:rPr sz="1200">
+                        <a:rPr sz="1200" dirty="0">
                           <a:solidFill>
                             <a:srgbClr val="333333"/>
                           </a:solidFill>
                           <a:latin typeface="Calibri"/>
                         </a:rPr>
-                        <a:t>Single binary – no JVM</a:t>
+                        <a:t>Single binary – no </a:t>
                       </a:r>
+                      <a:r>
+                        <a:rPr lang="en-US" sz="1200" dirty="0">
+                          <a:solidFill>
+                            <a:srgbClr val="333333"/>
+                          </a:solidFill>
+                          <a:latin typeface="Calibri"/>
+                        </a:rPr>
+                        <a:t>external dependencies</a:t>
+                      </a:r>
+                      <a:endParaRPr sz="1200" dirty="0">
+                        <a:solidFill>
+                          <a:srgbClr val="333333"/>
+                        </a:solidFill>
+                        <a:latin typeface="Calibri"/>
+                      </a:endParaRPr>
                     </a:p>
                   </a:txBody>
                   <a:tcPr>
@@ -6886,14 +6616,20 @@
                     <a:p>
                       <a:pPr algn="ctr"/>
                       <a:r>
-                        <a:rPr sz="1200">
+                        <a:rPr lang="en-US" sz="1200" b="1" dirty="0">
                           <a:solidFill>
-                            <a:srgbClr val="CC0000"/>
+                            <a:srgbClr val="009944"/>
                           </a:solidFill>
-                          <a:latin typeface="Calibri"/>
+                          <a:latin typeface="+mn-lt"/>
                         </a:rPr>
-                        <a:t>No</a:t>
+                        <a:t>Yes</a:t>
                       </a:r>
+                      <a:endParaRPr sz="1200" dirty="0">
+                        <a:solidFill>
+                          <a:srgbClr val="CC0000"/>
+                        </a:solidFill>
+                        <a:latin typeface="Calibri"/>
+                      </a:endParaRPr>
                     </a:p>
                   </a:txBody>
                   <a:tcPr>
@@ -6909,7 +6645,7 @@
                     <a:p>
                       <a:pPr algn="ctr"/>
                       <a:r>
-                        <a:rPr b="1" sz="1200">
+                        <a:rPr sz="1200" b="1" dirty="0">
                           <a:solidFill>
                             <a:srgbClr val="009944"/>
                           </a:solidFill>
@@ -6925,6 +6661,11 @@
                     </a:solidFill>
                   </a:tcPr>
                 </a:tc>
+                <a:extLst>
+                  <a:ext uri="{0D108BD9-81ED-4DB2-BD59-A6C34878D82A}">
+                    <a16:rowId xmlns:a16="http://schemas.microsoft.com/office/drawing/2014/main" val="10014"/>
+                  </a:ext>
+                </a:extLst>
               </a:tr>
               <a:tr h="340050">
                 <a:tc>
@@ -6980,7 +6721,7 @@
                     <a:p>
                       <a:pPr algn="ctr"/>
                       <a:r>
-                        <a:rPr b="1" sz="1200">
+                        <a:rPr sz="1200" b="1" dirty="0">
                           <a:solidFill>
                             <a:srgbClr val="009944"/>
                           </a:solidFill>
@@ -6996,6 +6737,11 @@
                     </a:solidFill>
                   </a:tcPr>
                 </a:tc>
+                <a:extLst>
+                  <a:ext uri="{0D108BD9-81ED-4DB2-BD59-A6C34878D82A}">
+                    <a16:rowId xmlns:a16="http://schemas.microsoft.com/office/drawing/2014/main" val="10015"/>
+                  </a:ext>
+                </a:extLst>
               </a:tr>
             </a:tbl>
           </a:graphicData>
@@ -7009,8 +6755,8 @@
 </p:sld>
 </file>
 
-<file path=ppt/slides/slide15.xml><?xml version="1.0" encoding="utf-8"?>
-<p:sld xmlns:a="http://schemas.openxmlformats.org/drawingml/2006/main" xmlns:p="http://schemas.openxmlformats.org/presentationml/2006/main" xmlns:r="http://schemas.openxmlformats.org/officeDocument/2006/relationships">
+<file path=ppt/slides/slide14.xml><?xml version="1.0" encoding="utf-8"?>
+<p:sld xmlns:a="http://schemas.openxmlformats.org/drawingml/2006/main" xmlns:r="http://schemas.openxmlformats.org/officeDocument/2006/relationships" xmlns:p="http://schemas.openxmlformats.org/presentationml/2006/main">
   <p:cSld>
     <p:spTree>
       <p:nvGrpSpPr>
@@ -7018,7 +6764,14 @@
         <p:cNvGrpSpPr/>
         <p:nvPr/>
       </p:nvGrpSpPr>
-      <p:grpSpPr/>
+      <p:grpSpPr>
+        <a:xfrm>
+          <a:off x="0" y="0"/>
+          <a:ext cx="0" cy="0"/>
+          <a:chOff x="0" y="0"/>
+          <a:chExt cx="0" cy="0"/>
+        </a:xfrm>
+      </p:grpSpPr>
       <p:sp>
         <p:nvSpPr>
           <p:cNvPr id="2" name="Rectangle 1"/>
@@ -7059,6 +6812,7 @@
           <a:lstStyle/>
           <a:p>
             <a:pPr algn="ctr"/>
+            <a:endParaRPr/>
           </a:p>
         </p:txBody>
       </p:sp>
@@ -7172,6 +6926,7 @@
           <a:lstStyle/>
           <a:p>
             <a:pPr algn="ctr"/>
+            <a:endParaRPr/>
           </a:p>
         </p:txBody>
       </p:sp>
@@ -7250,6 +7005,7 @@
           <a:lstStyle/>
           <a:p>
             <a:pPr algn="ctr"/>
+            <a:endParaRPr/>
           </a:p>
         </p:txBody>
       </p:sp>
@@ -7316,8 +7072,8 @@
 </p:sld>
 </file>
 
-<file path=ppt/slides/slide16.xml><?xml version="1.0" encoding="utf-8"?>
-<p:sld xmlns:a="http://schemas.openxmlformats.org/drawingml/2006/main" xmlns:p="http://schemas.openxmlformats.org/presentationml/2006/main" xmlns:r="http://schemas.openxmlformats.org/officeDocument/2006/relationships">
+<file path=ppt/slides/slide15.xml><?xml version="1.0" encoding="utf-8"?>
+<p:sld xmlns:a="http://schemas.openxmlformats.org/drawingml/2006/main" xmlns:r="http://schemas.openxmlformats.org/officeDocument/2006/relationships" xmlns:p="http://schemas.openxmlformats.org/presentationml/2006/main">
   <p:cSld>
     <p:spTree>
       <p:nvGrpSpPr>
@@ -7325,7 +7081,14 @@
         <p:cNvGrpSpPr/>
         <p:nvPr/>
       </p:nvGrpSpPr>
-      <p:grpSpPr/>
+      <p:grpSpPr>
+        <a:xfrm>
+          <a:off x="0" y="0"/>
+          <a:ext cx="0" cy="0"/>
+          <a:chOff x="0" y="0"/>
+          <a:chExt cx="0" cy="0"/>
+        </a:xfrm>
+      </p:grpSpPr>
       <p:sp>
         <p:nvSpPr>
           <p:cNvPr id="2" name="Rectangle 1"/>
@@ -7366,6 +7129,7 @@
           <a:lstStyle/>
           <a:p>
             <a:pPr algn="ctr"/>
+            <a:endParaRPr/>
           </a:p>
         </p:txBody>
       </p:sp>
@@ -7409,6 +7173,7 @@
           <a:lstStyle/>
           <a:p>
             <a:pPr algn="ctr"/>
+            <a:endParaRPr/>
           </a:p>
         </p:txBody>
       </p:sp>
@@ -7561,7 +7326,7 @@
 </file>
 
 <file path=ppt/slides/slide2.xml><?xml version="1.0" encoding="utf-8"?>
-<p:sld xmlns:a="http://schemas.openxmlformats.org/drawingml/2006/main" xmlns:p="http://schemas.openxmlformats.org/presentationml/2006/main" xmlns:r="http://schemas.openxmlformats.org/officeDocument/2006/relationships">
+<p:sld xmlns:a="http://schemas.openxmlformats.org/drawingml/2006/main" xmlns:r="http://schemas.openxmlformats.org/officeDocument/2006/relationships" xmlns:p="http://schemas.openxmlformats.org/presentationml/2006/main">
   <p:cSld>
     <p:spTree>
       <p:nvGrpSpPr>
@@ -7569,7 +7334,14 @@
         <p:cNvGrpSpPr/>
         <p:nvPr/>
       </p:nvGrpSpPr>
-      <p:grpSpPr/>
+      <p:grpSpPr>
+        <a:xfrm>
+          <a:off x="0" y="0"/>
+          <a:ext cx="0" cy="0"/>
+          <a:chOff x="0" y="0"/>
+          <a:chExt cx="0" cy="0"/>
+        </a:xfrm>
+      </p:grpSpPr>
       <p:sp>
         <p:nvSpPr>
           <p:cNvPr id="2" name="Rectangle 1"/>
@@ -7610,6 +7382,7 @@
           <a:lstStyle/>
           <a:p>
             <a:pPr algn="ctr"/>
+            <a:endParaRPr/>
           </a:p>
         </p:txBody>
       </p:sp>
@@ -7688,6 +7461,7 @@
           <a:lstStyle/>
           <a:p>
             <a:pPr algn="ctr"/>
+            <a:endParaRPr/>
           </a:p>
         </p:txBody>
       </p:sp>
@@ -7813,7 +7587,7 @@
         <p:spPr>
           <a:xfrm>
             <a:off x="6217920" y="1188720"/>
-            <a:ext cx="5486400" cy="5029200"/>
+            <a:ext cx="5486400" cy="1400383"/>
           </a:xfrm>
           <a:prstGeom prst="rect">
             <a:avLst/>
@@ -7827,7 +7601,7 @@
           <a:lstStyle/>
           <a:p>
             <a:r>
-              <a:rPr sz="1700" b="0">
+              <a:rPr sz="1700" b="0" dirty="0">
                 <a:solidFill>
                   <a:srgbClr val="333333"/>
                 </a:solidFill>
@@ -7838,7 +7612,7 @@
           </a:p>
           <a:p>
             <a:r>
-              <a:rPr sz="1700" b="0">
+              <a:rPr sz="1700" b="0" dirty="0">
                 <a:solidFill>
                   <a:srgbClr val="333333"/>
                 </a:solidFill>
@@ -7849,7 +7623,7 @@
           </a:p>
           <a:p>
             <a:r>
-              <a:rPr sz="1700" b="0">
+              <a:rPr sz="1700" b="0" dirty="0">
                 <a:solidFill>
                   <a:srgbClr val="333333"/>
                 </a:solidFill>
@@ -7860,18 +7634,18 @@
           </a:p>
           <a:p>
             <a:r>
-              <a:rPr sz="1700" b="0">
+              <a:rPr lang="en-US" sz="1700" b="0" dirty="0">
                 <a:solidFill>
                   <a:srgbClr val="333333"/>
                 </a:solidFill>
                 <a:latin typeface="Calibri"/>
               </a:rPr>
-              <a:t>  9.  Single Binary – No JVM Required</a:t>
-            </a:r>
-          </a:p>
-          <a:p>
-            <a:r>
-              <a:rPr sz="1700" b="0">
+              <a:t>  9.  Single Binary – No external dependencies required</a:t>
+            </a:r>
+          </a:p>
+          <a:p>
+            <a:r>
+              <a:rPr lang="en-US" sz="1700" b="0" dirty="0">
                 <a:solidFill>
                   <a:srgbClr val="333333"/>
                 </a:solidFill>
@@ -7891,7 +7665,7 @@
 </file>
 
 <file path=ppt/slides/slide3.xml><?xml version="1.0" encoding="utf-8"?>
-<p:sld xmlns:a="http://schemas.openxmlformats.org/drawingml/2006/main" xmlns:p="http://schemas.openxmlformats.org/presentationml/2006/main" xmlns:r="http://schemas.openxmlformats.org/officeDocument/2006/relationships">
+<p:sld xmlns:a="http://schemas.openxmlformats.org/drawingml/2006/main" xmlns:r="http://schemas.openxmlformats.org/officeDocument/2006/relationships" xmlns:p="http://schemas.openxmlformats.org/presentationml/2006/main">
   <p:cSld>
     <p:spTree>
       <p:nvGrpSpPr>
@@ -7899,7 +7673,14 @@
         <p:cNvGrpSpPr/>
         <p:nvPr/>
       </p:nvGrpSpPr>
-      <p:grpSpPr/>
+      <p:grpSpPr>
+        <a:xfrm>
+          <a:off x="0" y="0"/>
+          <a:ext cx="0" cy="0"/>
+          <a:chOff x="0" y="0"/>
+          <a:chExt cx="0" cy="0"/>
+        </a:xfrm>
+      </p:grpSpPr>
       <p:sp>
         <p:nvSpPr>
           <p:cNvPr id="2" name="Rectangle 1"/>
@@ -7940,6 +7721,7 @@
           <a:lstStyle/>
           <a:p>
             <a:pPr algn="ctr"/>
+            <a:endParaRPr/>
           </a:p>
         </p:txBody>
       </p:sp>
@@ -8053,6 +7835,7 @@
           <a:lstStyle/>
           <a:p>
             <a:pPr algn="ctr"/>
+            <a:endParaRPr/>
           </a:p>
         </p:txBody>
       </p:sp>
@@ -8233,7 +8016,7 @@
 </file>
 
 <file path=ppt/slides/slide4.xml><?xml version="1.0" encoding="utf-8"?>
-<p:sld xmlns:a="http://schemas.openxmlformats.org/drawingml/2006/main" xmlns:p="http://schemas.openxmlformats.org/presentationml/2006/main" xmlns:r="http://schemas.openxmlformats.org/officeDocument/2006/relationships">
+<p:sld xmlns:a="http://schemas.openxmlformats.org/drawingml/2006/main" xmlns:r="http://schemas.openxmlformats.org/officeDocument/2006/relationships" xmlns:p="http://schemas.openxmlformats.org/presentationml/2006/main">
   <p:cSld>
     <p:spTree>
       <p:nvGrpSpPr>
@@ -8241,7 +8024,14 @@
         <p:cNvGrpSpPr/>
         <p:nvPr/>
       </p:nvGrpSpPr>
-      <p:grpSpPr/>
+      <p:grpSpPr>
+        <a:xfrm>
+          <a:off x="0" y="0"/>
+          <a:ext cx="0" cy="0"/>
+          <a:chOff x="0" y="0"/>
+          <a:chExt cx="0" cy="0"/>
+        </a:xfrm>
+      </p:grpSpPr>
       <p:sp>
         <p:nvSpPr>
           <p:cNvPr id="2" name="Rectangle 1"/>
@@ -8282,6 +8072,7 @@
           <a:lstStyle/>
           <a:p>
             <a:pPr algn="ctr"/>
+            <a:endParaRPr/>
           </a:p>
         </p:txBody>
       </p:sp>
@@ -8395,6 +8186,7 @@
           <a:lstStyle/>
           <a:p>
             <a:pPr algn="ctr"/>
+            <a:endParaRPr/>
           </a:p>
         </p:txBody>
       </p:sp>
@@ -8508,6 +8300,7 @@
           <a:lstStyle/>
           <a:p>
             <a:pPr algn="ctr"/>
+            <a:endParaRPr/>
           </a:p>
         </p:txBody>
       </p:sp>
@@ -8624,6 +8417,7 @@
           <a:lstStyle/>
           <a:p>
             <a:pPr algn="ctr"/>
+            <a:endParaRPr/>
           </a:p>
         </p:txBody>
       </p:sp>
@@ -8684,9 +8478,27 @@
                 <a:tableStyleId>{5C22544A-7EE6-4342-B048-85BDC9FD1C3A}</a:tableStyleId>
               </a:tblPr>
               <a:tblGrid>
-                <a:gridCol w="2743200"/>
-                <a:gridCol w="2743200"/>
-                <a:gridCol w="2743200"/>
+                <a:gridCol w="2743200">
+                  <a:extLst>
+                    <a:ext uri="{9D8B030D-6E8A-4147-A177-3AD203B41FA5}">
+                      <a16:colId xmlns:a16="http://schemas.microsoft.com/office/drawing/2014/main" val="20000"/>
+                    </a:ext>
+                  </a:extLst>
+                </a:gridCol>
+                <a:gridCol w="2743200">
+                  <a:extLst>
+                    <a:ext uri="{9D8B030D-6E8A-4147-A177-3AD203B41FA5}">
+                      <a16:colId xmlns:a16="http://schemas.microsoft.com/office/drawing/2014/main" val="20001"/>
+                    </a:ext>
+                  </a:extLst>
+                </a:gridCol>
+                <a:gridCol w="2743200">
+                  <a:extLst>
+                    <a:ext uri="{9D8B030D-6E8A-4147-A177-3AD203B41FA5}">
+                      <a16:colId xmlns:a16="http://schemas.microsoft.com/office/drawing/2014/main" val="20002"/>
+                    </a:ext>
+                  </a:extLst>
+                </a:gridCol>
               </a:tblGrid>
               <a:tr h="388620">
                 <a:tc>
@@ -8696,7 +8508,7 @@
                     <a:p>
                       <a:pPr algn="ctr"/>
                       <a:r>
-                        <a:rPr b="1" sz="1300">
+                        <a:rPr sz="1300" b="1">
                           <a:solidFill>
                             <a:srgbClr val="FFFFFF"/>
                           </a:solidFill>
@@ -8719,7 +8531,7 @@
                     <a:p>
                       <a:pPr algn="ctr"/>
                       <a:r>
-                        <a:rPr b="1" sz="1300">
+                        <a:rPr sz="1300" b="1">
                           <a:solidFill>
                             <a:srgbClr val="FFFFFF"/>
                           </a:solidFill>
@@ -8742,7 +8554,7 @@
                     <a:p>
                       <a:pPr algn="ctr"/>
                       <a:r>
-                        <a:rPr b="1" sz="1300">
+                        <a:rPr sz="1300" b="1">
                           <a:solidFill>
                             <a:srgbClr val="FFFFFF"/>
                           </a:solidFill>
@@ -8758,6 +8570,11 @@
                     </a:solidFill>
                   </a:tcPr>
                 </a:tc>
+                <a:extLst>
+                  <a:ext uri="{0D108BD9-81ED-4DB2-BD59-A6C34878D82A}">
+                    <a16:rowId xmlns:a16="http://schemas.microsoft.com/office/drawing/2014/main" val="10000"/>
+                  </a:ext>
+                </a:extLst>
               </a:tr>
               <a:tr h="388620">
                 <a:tc>
@@ -8829,6 +8646,11 @@
                     </a:solidFill>
                   </a:tcPr>
                 </a:tc>
+                <a:extLst>
+                  <a:ext uri="{0D108BD9-81ED-4DB2-BD59-A6C34878D82A}">
+                    <a16:rowId xmlns:a16="http://schemas.microsoft.com/office/drawing/2014/main" val="10001"/>
+                  </a:ext>
+                </a:extLst>
               </a:tr>
               <a:tr h="388620">
                 <a:tc>
@@ -8900,6 +8722,11 @@
                     </a:solidFill>
                   </a:tcPr>
                 </a:tc>
+                <a:extLst>
+                  <a:ext uri="{0D108BD9-81ED-4DB2-BD59-A6C34878D82A}">
+                    <a16:rowId xmlns:a16="http://schemas.microsoft.com/office/drawing/2014/main" val="10002"/>
+                  </a:ext>
+                </a:extLst>
               </a:tr>
               <a:tr h="388620">
                 <a:tc>
@@ -8971,6 +8798,11 @@
                     </a:solidFill>
                   </a:tcPr>
                 </a:tc>
+                <a:extLst>
+                  <a:ext uri="{0D108BD9-81ED-4DB2-BD59-A6C34878D82A}">
+                    <a16:rowId xmlns:a16="http://schemas.microsoft.com/office/drawing/2014/main" val="10003"/>
+                  </a:ext>
+                </a:extLst>
               </a:tr>
             </a:tbl>
           </a:graphicData>
@@ -9020,7 +8852,7 @@
 </file>
 
 <file path=ppt/slides/slide5.xml><?xml version="1.0" encoding="utf-8"?>
-<p:sld xmlns:a="http://schemas.openxmlformats.org/drawingml/2006/main" xmlns:p="http://schemas.openxmlformats.org/presentationml/2006/main" xmlns:r="http://schemas.openxmlformats.org/officeDocument/2006/relationships">
+<p:sld xmlns:a="http://schemas.openxmlformats.org/drawingml/2006/main" xmlns:r="http://schemas.openxmlformats.org/officeDocument/2006/relationships" xmlns:p="http://schemas.openxmlformats.org/presentationml/2006/main">
   <p:cSld>
     <p:spTree>
       <p:nvGrpSpPr>
@@ -9028,7 +8860,14 @@
         <p:cNvGrpSpPr/>
         <p:nvPr/>
       </p:nvGrpSpPr>
-      <p:grpSpPr/>
+      <p:grpSpPr>
+        <a:xfrm>
+          <a:off x="0" y="0"/>
+          <a:ext cx="0" cy="0"/>
+          <a:chOff x="0" y="0"/>
+          <a:chExt cx="0" cy="0"/>
+        </a:xfrm>
+      </p:grpSpPr>
       <p:sp>
         <p:nvSpPr>
           <p:cNvPr id="2" name="Rectangle 1"/>
@@ -9069,6 +8908,7 @@
           <a:lstStyle/>
           <a:p>
             <a:pPr algn="ctr"/>
+            <a:endParaRPr/>
           </a:p>
         </p:txBody>
       </p:sp>
@@ -9182,6 +9022,7 @@
           <a:lstStyle/>
           <a:p>
             <a:pPr algn="ctr"/>
+            <a:endParaRPr/>
           </a:p>
         </p:txBody>
       </p:sp>
@@ -9295,6 +9136,7 @@
           <a:lstStyle/>
           <a:p>
             <a:pPr algn="ctr"/>
+            <a:endParaRPr/>
           </a:p>
         </p:txBody>
       </p:sp>
@@ -9387,7 +9229,7 @@
 </file>
 
 <file path=ppt/slides/slide6.xml><?xml version="1.0" encoding="utf-8"?>
-<p:sld xmlns:a="http://schemas.openxmlformats.org/drawingml/2006/main" xmlns:p="http://schemas.openxmlformats.org/presentationml/2006/main" xmlns:r="http://schemas.openxmlformats.org/officeDocument/2006/relationships">
+<p:sld xmlns:a="http://schemas.openxmlformats.org/drawingml/2006/main" xmlns:r="http://schemas.openxmlformats.org/officeDocument/2006/relationships" xmlns:p="http://schemas.openxmlformats.org/presentationml/2006/main">
   <p:cSld>
     <p:spTree>
       <p:nvGrpSpPr>
@@ -9395,7 +9237,14 @@
         <p:cNvGrpSpPr/>
         <p:nvPr/>
       </p:nvGrpSpPr>
-      <p:grpSpPr/>
+      <p:grpSpPr>
+        <a:xfrm>
+          <a:off x="0" y="0"/>
+          <a:ext cx="0" cy="0"/>
+          <a:chOff x="0" y="0"/>
+          <a:chExt cx="0" cy="0"/>
+        </a:xfrm>
+      </p:grpSpPr>
       <p:sp>
         <p:nvSpPr>
           <p:cNvPr id="2" name="Rectangle 1"/>
@@ -9436,6 +9285,7 @@
           <a:lstStyle/>
           <a:p>
             <a:pPr algn="ctr"/>
+            <a:endParaRPr/>
           </a:p>
         </p:txBody>
       </p:sp>
@@ -9549,6 +9399,7 @@
           <a:lstStyle/>
           <a:p>
             <a:pPr algn="ctr"/>
+            <a:endParaRPr/>
           </a:p>
         </p:txBody>
       </p:sp>
@@ -9662,6 +9513,7 @@
           <a:lstStyle/>
           <a:p>
             <a:pPr algn="ctr"/>
+            <a:endParaRPr/>
           </a:p>
         </p:txBody>
       </p:sp>
@@ -9780,6 +9632,7 @@
           <a:lstStyle/>
           <a:p>
             <a:pPr algn="ctr"/>
+            <a:endParaRPr/>
           </a:p>
         </p:txBody>
       </p:sp>
@@ -9902,7 +9755,7 @@
 </file>
 
 <file path=ppt/slides/slide7.xml><?xml version="1.0" encoding="utf-8"?>
-<p:sld xmlns:a="http://schemas.openxmlformats.org/drawingml/2006/main" xmlns:p="http://schemas.openxmlformats.org/presentationml/2006/main" xmlns:r="http://schemas.openxmlformats.org/officeDocument/2006/relationships">
+<p:sld xmlns:a="http://schemas.openxmlformats.org/drawingml/2006/main" xmlns:r="http://schemas.openxmlformats.org/officeDocument/2006/relationships" xmlns:p="http://schemas.openxmlformats.org/presentationml/2006/main">
   <p:cSld>
     <p:spTree>
       <p:nvGrpSpPr>
@@ -9910,7 +9763,14 @@
         <p:cNvGrpSpPr/>
         <p:nvPr/>
       </p:nvGrpSpPr>
-      <p:grpSpPr/>
+      <p:grpSpPr>
+        <a:xfrm>
+          <a:off x="0" y="0"/>
+          <a:ext cx="0" cy="0"/>
+          <a:chOff x="0" y="0"/>
+          <a:chExt cx="0" cy="0"/>
+        </a:xfrm>
+      </p:grpSpPr>
       <p:sp>
         <p:nvSpPr>
           <p:cNvPr id="2" name="Rectangle 1"/>
@@ -9951,6 +9811,7 @@
           <a:lstStyle/>
           <a:p>
             <a:pPr algn="ctr"/>
+            <a:endParaRPr/>
           </a:p>
         </p:txBody>
       </p:sp>
@@ -10064,6 +9925,7 @@
           <a:lstStyle/>
           <a:p>
             <a:pPr algn="ctr"/>
+            <a:endParaRPr/>
           </a:p>
         </p:txBody>
       </p:sp>
@@ -10142,6 +10004,7 @@
           <a:lstStyle/>
           <a:p>
             <a:pPr algn="ctr"/>
+            <a:endParaRPr/>
           </a:p>
         </p:txBody>
       </p:sp>
@@ -10269,6 +10132,7 @@
           <a:lstStyle/>
           <a:p>
             <a:pPr algn="ctr"/>
+            <a:endParaRPr/>
           </a:p>
         </p:txBody>
       </p:sp>
@@ -10382,7 +10246,7 @@
 </file>
 
 <file path=ppt/slides/slide8.xml><?xml version="1.0" encoding="utf-8"?>
-<p:sld xmlns:a="http://schemas.openxmlformats.org/drawingml/2006/main" xmlns:p="http://schemas.openxmlformats.org/presentationml/2006/main" xmlns:r="http://schemas.openxmlformats.org/officeDocument/2006/relationships">
+<p:sld xmlns:a="http://schemas.openxmlformats.org/drawingml/2006/main" xmlns:r="http://schemas.openxmlformats.org/officeDocument/2006/relationships" xmlns:p="http://schemas.openxmlformats.org/presentationml/2006/main">
   <p:cSld>
     <p:spTree>
       <p:nvGrpSpPr>
@@ -10390,7 +10254,14 @@
         <p:cNvGrpSpPr/>
         <p:nvPr/>
       </p:nvGrpSpPr>
-      <p:grpSpPr/>
+      <p:grpSpPr>
+        <a:xfrm>
+          <a:off x="0" y="0"/>
+          <a:ext cx="0" cy="0"/>
+          <a:chOff x="0" y="0"/>
+          <a:chExt cx="0" cy="0"/>
+        </a:xfrm>
+      </p:grpSpPr>
       <p:sp>
         <p:nvSpPr>
           <p:cNvPr id="2" name="Rectangle 1"/>
@@ -10431,6 +10302,7 @@
           <a:lstStyle/>
           <a:p>
             <a:pPr algn="ctr"/>
+            <a:endParaRPr/>
           </a:p>
         </p:txBody>
       </p:sp>
@@ -10544,6 +10416,7 @@
           <a:lstStyle/>
           <a:p>
             <a:pPr algn="ctr"/>
+            <a:endParaRPr/>
           </a:p>
         </p:txBody>
       </p:sp>
@@ -10748,6 +10621,7 @@
           <a:lstStyle/>
           <a:p>
             <a:pPr algn="ctr"/>
+            <a:endParaRPr/>
           </a:p>
         </p:txBody>
       </p:sp>
@@ -10868,7 +10742,7 @@
 </file>
 
 <file path=ppt/slides/slide9.xml><?xml version="1.0" encoding="utf-8"?>
-<p:sld xmlns:a="http://schemas.openxmlformats.org/drawingml/2006/main" xmlns:p="http://schemas.openxmlformats.org/presentationml/2006/main" xmlns:r="http://schemas.openxmlformats.org/officeDocument/2006/relationships">
+<p:sld xmlns:a="http://schemas.openxmlformats.org/drawingml/2006/main" xmlns:r="http://schemas.openxmlformats.org/officeDocument/2006/relationships" xmlns:p="http://schemas.openxmlformats.org/presentationml/2006/main">
   <p:cSld>
     <p:spTree>
       <p:nvGrpSpPr>
@@ -10876,7 +10750,14 @@
         <p:cNvGrpSpPr/>
         <p:nvPr/>
       </p:nvGrpSpPr>
-      <p:grpSpPr/>
+      <p:grpSpPr>
+        <a:xfrm>
+          <a:off x="0" y="0"/>
+          <a:ext cx="0" cy="0"/>
+          <a:chOff x="0" y="0"/>
+          <a:chExt cx="0" cy="0"/>
+        </a:xfrm>
+      </p:grpSpPr>
       <p:sp>
         <p:nvSpPr>
           <p:cNvPr id="2" name="Rectangle 1"/>
@@ -10917,6 +10798,7 @@
           <a:lstStyle/>
           <a:p>
             <a:pPr algn="ctr"/>
+            <a:endParaRPr/>
           </a:p>
         </p:txBody>
       </p:sp>
@@ -11030,6 +10912,7 @@
           <a:lstStyle/>
           <a:p>
             <a:pPr algn="ctr"/>
+            <a:endParaRPr/>
           </a:p>
         </p:txBody>
       </p:sp>
@@ -11087,8 +10970,20 @@
                 <a:tableStyleId>{5C22544A-7EE6-4342-B048-85BDC9FD1C3A}</a:tableStyleId>
               </a:tblPr>
               <a:tblGrid>
-                <a:gridCol w="2743200"/>
-                <a:gridCol w="2743200"/>
+                <a:gridCol w="2743200">
+                  <a:extLst>
+                    <a:ext uri="{9D8B030D-6E8A-4147-A177-3AD203B41FA5}">
+                      <a16:colId xmlns:a16="http://schemas.microsoft.com/office/drawing/2014/main" val="20000"/>
+                    </a:ext>
+                  </a:extLst>
+                </a:gridCol>
+                <a:gridCol w="2743200">
+                  <a:extLst>
+                    <a:ext uri="{9D8B030D-6E8A-4147-A177-3AD203B41FA5}">
+                      <a16:colId xmlns:a16="http://schemas.microsoft.com/office/drawing/2014/main" val="20001"/>
+                    </a:ext>
+                  </a:extLst>
+                </a:gridCol>
               </a:tblGrid>
               <a:tr h="473825">
                 <a:tc>
@@ -11098,7 +10993,7 @@
                     <a:p>
                       <a:pPr algn="ctr"/>
                       <a:r>
-                        <a:rPr b="1" sz="1300">
+                        <a:rPr sz="1300" b="1">
                           <a:solidFill>
                             <a:srgbClr val="FFFFFF"/>
                           </a:solidFill>
@@ -11121,7 +11016,7 @@
                     <a:p>
                       <a:pPr algn="ctr"/>
                       <a:r>
-                        <a:rPr b="1" sz="1300">
+                        <a:rPr sz="1300" b="1">
                           <a:solidFill>
                             <a:srgbClr val="FFFFFF"/>
                           </a:solidFill>
@@ -11137,6 +11032,11 @@
                     </a:solidFill>
                   </a:tcPr>
                 </a:tc>
+                <a:extLst>
+                  <a:ext uri="{0D108BD9-81ED-4DB2-BD59-A6C34878D82A}">
+                    <a16:rowId xmlns:a16="http://schemas.microsoft.com/office/drawing/2014/main" val="10000"/>
+                  </a:ext>
+                </a:extLst>
               </a:tr>
               <a:tr h="473825">
                 <a:tc>
@@ -11185,6 +11085,11 @@
                     </a:solidFill>
                   </a:tcPr>
                 </a:tc>
+                <a:extLst>
+                  <a:ext uri="{0D108BD9-81ED-4DB2-BD59-A6C34878D82A}">
+                    <a16:rowId xmlns:a16="http://schemas.microsoft.com/office/drawing/2014/main" val="10001"/>
+                  </a:ext>
+                </a:extLst>
               </a:tr>
               <a:tr h="473825">
                 <a:tc>
@@ -11233,6 +11138,11 @@
                     </a:solidFill>
                   </a:tcPr>
                 </a:tc>
+                <a:extLst>
+                  <a:ext uri="{0D108BD9-81ED-4DB2-BD59-A6C34878D82A}">
+                    <a16:rowId xmlns:a16="http://schemas.microsoft.com/office/drawing/2014/main" val="10002"/>
+                  </a:ext>
+                </a:extLst>
               </a:tr>
               <a:tr h="473825">
                 <a:tc>
@@ -11281,6 +11191,11 @@
                     </a:solidFill>
                   </a:tcPr>
                 </a:tc>
+                <a:extLst>
+                  <a:ext uri="{0D108BD9-81ED-4DB2-BD59-A6C34878D82A}">
+                    <a16:rowId xmlns:a16="http://schemas.microsoft.com/office/drawing/2014/main" val="10003"/>
+                  </a:ext>
+                </a:extLst>
               </a:tr>
               <a:tr h="473825">
                 <a:tc>
@@ -11329,6 +11244,11 @@
                     </a:solidFill>
                   </a:tcPr>
                 </a:tc>
+                <a:extLst>
+                  <a:ext uri="{0D108BD9-81ED-4DB2-BD59-A6C34878D82A}">
+                    <a16:rowId xmlns:a16="http://schemas.microsoft.com/office/drawing/2014/main" val="10004"/>
+                  </a:ext>
+                </a:extLst>
               </a:tr>
               <a:tr h="473825">
                 <a:tc>
@@ -11377,6 +11297,11 @@
                     </a:solidFill>
                   </a:tcPr>
                 </a:tc>
+                <a:extLst>
+                  <a:ext uri="{0D108BD9-81ED-4DB2-BD59-A6C34878D82A}">
+                    <a16:rowId xmlns:a16="http://schemas.microsoft.com/office/drawing/2014/main" val="10005"/>
+                  </a:ext>
+                </a:extLst>
               </a:tr>
               <a:tr h="473825">
                 <a:tc>
@@ -11425,6 +11350,11 @@
                     </a:solidFill>
                   </a:tcPr>
                 </a:tc>
+                <a:extLst>
+                  <a:ext uri="{0D108BD9-81ED-4DB2-BD59-A6C34878D82A}">
+                    <a16:rowId xmlns:a16="http://schemas.microsoft.com/office/drawing/2014/main" val="10006"/>
+                  </a:ext>
+                </a:extLst>
               </a:tr>
               <a:tr h="473825">
                 <a:tc>
@@ -11473,6 +11403,11 @@
                     </a:solidFill>
                   </a:tcPr>
                 </a:tc>
+                <a:extLst>
+                  <a:ext uri="{0D108BD9-81ED-4DB2-BD59-A6C34878D82A}">
+                    <a16:rowId xmlns:a16="http://schemas.microsoft.com/office/drawing/2014/main" val="10007"/>
+                  </a:ext>
+                </a:extLst>
               </a:tr>
               <a:tr h="473825">
                 <a:tc>
@@ -11521,6 +11456,11 @@
                     </a:solidFill>
                   </a:tcPr>
                 </a:tc>
+                <a:extLst>
+                  <a:ext uri="{0D108BD9-81ED-4DB2-BD59-A6C34878D82A}">
+                    <a16:rowId xmlns:a16="http://schemas.microsoft.com/office/drawing/2014/main" val="10008"/>
+                  </a:ext>
+                </a:extLst>
               </a:tr>
               <a:tr h="473825">
                 <a:tc>
@@ -11569,6 +11509,11 @@
                     </a:solidFill>
                   </a:tcPr>
                 </a:tc>
+                <a:extLst>
+                  <a:ext uri="{0D108BD9-81ED-4DB2-BD59-A6C34878D82A}">
+                    <a16:rowId xmlns:a16="http://schemas.microsoft.com/office/drawing/2014/main" val="10009"/>
+                  </a:ext>
+                </a:extLst>
               </a:tr>
               <a:tr h="473830">
                 <a:tc>
@@ -11617,6 +11562,11 @@
                     </a:solidFill>
                   </a:tcPr>
                 </a:tc>
+                <a:extLst>
+                  <a:ext uri="{0D108BD9-81ED-4DB2-BD59-A6C34878D82A}">
+                    <a16:rowId xmlns:a16="http://schemas.microsoft.com/office/drawing/2014/main" val="10010"/>
+                  </a:ext>
+                </a:extLst>
               </a:tr>
             </a:tbl>
           </a:graphicData>
@@ -11641,8 +11591,20 @@
                 <a:tableStyleId>{5C22544A-7EE6-4342-B048-85BDC9FD1C3A}</a:tableStyleId>
               </a:tblPr>
               <a:tblGrid>
-                <a:gridCol w="2743200"/>
-                <a:gridCol w="2743200"/>
+                <a:gridCol w="2743200">
+                  <a:extLst>
+                    <a:ext uri="{9D8B030D-6E8A-4147-A177-3AD203B41FA5}">
+                      <a16:colId xmlns:a16="http://schemas.microsoft.com/office/drawing/2014/main" val="20000"/>
+                    </a:ext>
+                  </a:extLst>
+                </a:gridCol>
+                <a:gridCol w="2743200">
+                  <a:extLst>
+                    <a:ext uri="{9D8B030D-6E8A-4147-A177-3AD203B41FA5}">
+                      <a16:colId xmlns:a16="http://schemas.microsoft.com/office/drawing/2014/main" val="20001"/>
+                    </a:ext>
+                  </a:extLst>
+                </a:gridCol>
               </a:tblGrid>
               <a:tr h="473825">
                 <a:tc>
@@ -11652,7 +11614,7 @@
                     <a:p>
                       <a:pPr algn="ctr"/>
                       <a:r>
-                        <a:rPr b="1" sz="1300">
+                        <a:rPr sz="1300" b="1">
                           <a:solidFill>
                             <a:srgbClr val="FFFFFF"/>
                           </a:solidFill>
@@ -11675,7 +11637,7 @@
                     <a:p>
                       <a:pPr algn="ctr"/>
                       <a:r>
-                        <a:rPr b="1" sz="1300">
+                        <a:rPr sz="1300" b="1">
                           <a:solidFill>
                             <a:srgbClr val="FFFFFF"/>
                           </a:solidFill>
@@ -11691,6 +11653,11 @@
                     </a:solidFill>
                   </a:tcPr>
                 </a:tc>
+                <a:extLst>
+                  <a:ext uri="{0D108BD9-81ED-4DB2-BD59-A6C34878D82A}">
+                    <a16:rowId xmlns:a16="http://schemas.microsoft.com/office/drawing/2014/main" val="10000"/>
+                  </a:ext>
+                </a:extLst>
               </a:tr>
               <a:tr h="473825">
                 <a:tc>
@@ -11739,6 +11706,11 @@
                     </a:solidFill>
                   </a:tcPr>
                 </a:tc>
+                <a:extLst>
+                  <a:ext uri="{0D108BD9-81ED-4DB2-BD59-A6C34878D82A}">
+                    <a16:rowId xmlns:a16="http://schemas.microsoft.com/office/drawing/2014/main" val="10001"/>
+                  </a:ext>
+                </a:extLst>
               </a:tr>
               <a:tr h="473825">
                 <a:tc>
@@ -11787,6 +11759,11 @@
                     </a:solidFill>
                   </a:tcPr>
                 </a:tc>
+                <a:extLst>
+                  <a:ext uri="{0D108BD9-81ED-4DB2-BD59-A6C34878D82A}">
+                    <a16:rowId xmlns:a16="http://schemas.microsoft.com/office/drawing/2014/main" val="10002"/>
+                  </a:ext>
+                </a:extLst>
               </a:tr>
               <a:tr h="473825">
                 <a:tc>
@@ -11835,6 +11812,11 @@
                     </a:solidFill>
                   </a:tcPr>
                 </a:tc>
+                <a:extLst>
+                  <a:ext uri="{0D108BD9-81ED-4DB2-BD59-A6C34878D82A}">
+                    <a16:rowId xmlns:a16="http://schemas.microsoft.com/office/drawing/2014/main" val="10003"/>
+                  </a:ext>
+                </a:extLst>
               </a:tr>
               <a:tr h="473825">
                 <a:tc>
@@ -11883,6 +11865,11 @@
                     </a:solidFill>
                   </a:tcPr>
                 </a:tc>
+                <a:extLst>
+                  <a:ext uri="{0D108BD9-81ED-4DB2-BD59-A6C34878D82A}">
+                    <a16:rowId xmlns:a16="http://schemas.microsoft.com/office/drawing/2014/main" val="10004"/>
+                  </a:ext>
+                </a:extLst>
               </a:tr>
               <a:tr h="473825">
                 <a:tc>
@@ -11931,6 +11918,11 @@
                     </a:solidFill>
                   </a:tcPr>
                 </a:tc>
+                <a:extLst>
+                  <a:ext uri="{0D108BD9-81ED-4DB2-BD59-A6C34878D82A}">
+                    <a16:rowId xmlns:a16="http://schemas.microsoft.com/office/drawing/2014/main" val="10005"/>
+                  </a:ext>
+                </a:extLst>
               </a:tr>
               <a:tr h="473825">
                 <a:tc>
@@ -11979,6 +11971,11 @@
                     </a:solidFill>
                   </a:tcPr>
                 </a:tc>
+                <a:extLst>
+                  <a:ext uri="{0D108BD9-81ED-4DB2-BD59-A6C34878D82A}">
+                    <a16:rowId xmlns:a16="http://schemas.microsoft.com/office/drawing/2014/main" val="10006"/>
+                  </a:ext>
+                </a:extLst>
               </a:tr>
               <a:tr h="473825">
                 <a:tc>
@@ -12027,6 +12024,11 @@
                     </a:solidFill>
                   </a:tcPr>
                 </a:tc>
+                <a:extLst>
+                  <a:ext uri="{0D108BD9-81ED-4DB2-BD59-A6C34878D82A}">
+                    <a16:rowId xmlns:a16="http://schemas.microsoft.com/office/drawing/2014/main" val="10007"/>
+                  </a:ext>
+                </a:extLst>
               </a:tr>
               <a:tr h="473825">
                 <a:tc>
@@ -12075,6 +12077,11 @@
                     </a:solidFill>
                   </a:tcPr>
                 </a:tc>
+                <a:extLst>
+                  <a:ext uri="{0D108BD9-81ED-4DB2-BD59-A6C34878D82A}">
+                    <a16:rowId xmlns:a16="http://schemas.microsoft.com/office/drawing/2014/main" val="10008"/>
+                  </a:ext>
+                </a:extLst>
               </a:tr>
               <a:tr h="473825">
                 <a:tc>
@@ -12123,6 +12130,11 @@
                     </a:solidFill>
                   </a:tcPr>
                 </a:tc>
+                <a:extLst>
+                  <a:ext uri="{0D108BD9-81ED-4DB2-BD59-A6C34878D82A}">
+                    <a16:rowId xmlns:a16="http://schemas.microsoft.com/office/drawing/2014/main" val="10009"/>
+                  </a:ext>
+                </a:extLst>
               </a:tr>
               <a:tr h="473830">
                 <a:tc>
@@ -12171,6 +12183,11 @@
                     </a:solidFill>
                   </a:tcPr>
                 </a:tc>
+                <a:extLst>
+                  <a:ext uri="{0D108BD9-81ED-4DB2-BD59-A6C34878D82A}">
+                    <a16:rowId xmlns:a16="http://schemas.microsoft.com/office/drawing/2014/main" val="10010"/>
+                  </a:ext>
+                </a:extLst>
               </a:tr>
             </a:tbl>
           </a:graphicData>

</xml_diff>